<commit_message>
Business plan; deck competition progress
Co-Authored-By: Claude Opus 5.5 <noreply@anthropic.com>
Claude-Session: https://claude.ai/code/session_01Q1YFQVkqvZuZSxHETxCkHf
</commit_message>
<xml_diff>
--- a/competitions/deck-knock-partner-pitch/entry-1/deck.pptx
+++ b/competitions/deck-knock-partner-pitch/entry-1/deck.pptx
@@ -642,9 +642,9 @@
         <p:grpSpPr>
           <a:xfrm>
             <a:off x="590550" y="1727200"/>
-            <a:ext cx="4423282" cy="2796794"/>
+            <a:ext cx="4423282" cy="2911094"/>
             <a:chOff x="590550" y="1727200"/>
-            <a:chExt cx="4423282" cy="2796794"/>
+            <a:chExt cx="4423282" cy="2911094"/>
           </a:xfrm>
         </p:grpSpPr>
         <p:sp>
@@ -656,7 +656,7 @@
           <p:spPr>
             <a:xfrm>
               <a:off x="603885" y="1727200"/>
-              <a:ext cx="2199790" cy="220028"/>
+              <a:ext cx="2940237" cy="220028"/>
             </a:xfrm>
             <a:prstGeom prst="rect">
               <a:avLst/>
@@ -667,7 +667,7 @@
             </a:ln>
           </p:spPr>
           <p:txBody>
-            <a:bodyPr wrap="none" lIns="0" tIns="0" rIns="0" bIns="0" anchor="t" anchorCtr="0">
+            <a:bodyPr wrap="square" lIns="0" tIns="0" rIns="0" bIns="0" anchor="t" anchorCtr="0">
               <a:spAutoFit/>
             </a:bodyPr>
             <a:lstStyle/>
@@ -718,7 +718,7 @@
           <p:spPr>
             <a:xfrm>
               <a:off x="590550" y="2387600"/>
-              <a:ext cx="4040977" cy="1866900"/>
+              <a:ext cx="4856645" cy="1866900"/>
             </a:xfrm>
             <a:prstGeom prst="rect">
               <a:avLst/>
@@ -729,7 +729,7 @@
             </a:ln>
           </p:spPr>
           <p:txBody>
-            <a:bodyPr wrap="none" lIns="0" tIns="0" rIns="0" bIns="0" anchor="t" anchorCtr="0">
+            <a:bodyPr wrap="square" lIns="0" tIns="0" rIns="0" bIns="0" anchor="t" anchorCtr="0">
               <a:spAutoFit/>
             </a:bodyPr>
             <a:lstStyle/>
@@ -782,8 +782,8 @@
           </p:nvSpPr>
           <p:spPr>
             <a:xfrm>
-              <a:off x="600456" y="4171950"/>
-              <a:ext cx="4413376" cy="352044"/>
+              <a:off x="600456" y="4286250"/>
+              <a:ext cx="5707220" cy="352044"/>
             </a:xfrm>
             <a:prstGeom prst="rect">
               <a:avLst/>
@@ -794,7 +794,7 @@
             </a:ln>
           </p:spPr>
           <p:txBody>
-            <a:bodyPr wrap="none" lIns="0" tIns="0" rIns="0" bIns="0" anchor="t" anchorCtr="0">
+            <a:bodyPr wrap="square" lIns="0" tIns="0" rIns="0" bIns="0" anchor="t" anchorCtr="0">
               <a:spAutoFit/>
             </a:bodyPr>
             <a:lstStyle/>
@@ -834,9 +834,9 @@
         </p:nvGrpSpPr>
         <p:grpSpPr>
           <a:xfrm>
-            <a:off x="601980" y="4889500"/>
+            <a:off x="601980" y="5003800"/>
             <a:ext cx="5373510" cy="579120"/>
-            <a:chOff x="601980" y="4889500"/>
+            <a:chOff x="601980" y="5003800"/>
             <a:chExt cx="5373510" cy="579120"/>
           </a:xfrm>
         </p:grpSpPr>
@@ -848,8 +848,8 @@
           </p:nvSpPr>
           <p:spPr>
             <a:xfrm>
-              <a:off x="601980" y="4889500"/>
-              <a:ext cx="5373510" cy="579120"/>
+              <a:off x="601980" y="5003800"/>
+              <a:ext cx="6907387" cy="579120"/>
             </a:xfrm>
             <a:prstGeom prst="rect">
               <a:avLst/>
@@ -860,7 +860,7 @@
             </a:ln>
           </p:spPr>
           <p:txBody>
-            <a:bodyPr wrap="none" lIns="0" tIns="0" rIns="0" bIns="0" anchor="t" anchorCtr="0">
+            <a:bodyPr wrap="square" lIns="0" tIns="0" rIns="0" bIns="0" anchor="t" anchorCtr="0">
               <a:spAutoFit/>
             </a:bodyPr>
             <a:lstStyle/>
@@ -1195,7 +1195,7 @@
           <p:spPr>
             <a:xfrm>
               <a:off x="601218" y="6235700"/>
-              <a:ext cx="705478" cy="322707"/>
+              <a:ext cx="1027098" cy="322707"/>
             </a:xfrm>
             <a:prstGeom prst="rect">
               <a:avLst/>
@@ -1206,7 +1206,7 @@
             </a:ln>
           </p:spPr>
           <p:txBody>
-            <a:bodyPr wrap="none" lIns="0" tIns="0" rIns="0" bIns="0" anchor="t" anchorCtr="0">
+            <a:bodyPr wrap="square" lIns="0" tIns="0" rIns="0" bIns="0" anchor="t" anchorCtr="0">
               <a:spAutoFit/>
             </a:bodyPr>
             <a:lstStyle/>
@@ -1235,7 +1235,7 @@
           <p:spPr>
             <a:xfrm>
               <a:off x="1423035" y="6289675"/>
-              <a:ext cx="1421608" cy="220028"/>
+              <a:ext cx="1967510" cy="220028"/>
             </a:xfrm>
             <a:prstGeom prst="rect">
               <a:avLst/>
@@ -1246,7 +1246,7 @@
             </a:ln>
           </p:spPr>
           <p:txBody>
-            <a:bodyPr wrap="none" lIns="0" tIns="0" rIns="0" bIns="0" anchor="t" anchorCtr="0">
+            <a:bodyPr wrap="square" lIns="0" tIns="0" rIns="0" bIns="0" anchor="t" anchorCtr="0">
               <a:spAutoFit/>
             </a:bodyPr>
             <a:lstStyle/>
@@ -1312,9 +1312,9 @@
         <p:grpSpPr>
           <a:xfrm>
             <a:off x="594360" y="565150"/>
-            <a:ext cx="8931812" cy="1118870"/>
+            <a:ext cx="8181077" cy="1118870"/>
             <a:chOff x="594360" y="565150"/>
-            <a:chExt cx="8931812" cy="1118870"/>
+            <a:chExt cx="8181077" cy="1118870"/>
           </a:xfrm>
         </p:grpSpPr>
         <p:sp>
@@ -1326,7 +1326,7 @@
           <p:spPr>
             <a:xfrm>
               <a:off x="603885" y="565150"/>
-              <a:ext cx="3090500" cy="220028"/>
+              <a:ext cx="4053625" cy="220028"/>
             </a:xfrm>
             <a:prstGeom prst="rect">
               <a:avLst/>
@@ -1337,7 +1337,7 @@
             </a:ln>
           </p:spPr>
           <p:txBody>
-            <a:bodyPr wrap="none" lIns="0" tIns="0" rIns="0" bIns="0" anchor="t" anchorCtr="0">
+            <a:bodyPr wrap="square" lIns="0" tIns="0" rIns="0" bIns="0" anchor="t" anchorCtr="0">
               <a:spAutoFit/>
             </a:bodyPr>
             <a:lstStyle/>
@@ -1366,7 +1366,7 @@
           <p:spPr>
             <a:xfrm>
               <a:off x="594360" y="850900"/>
-              <a:ext cx="8931812" cy="586740"/>
+              <a:ext cx="10416846" cy="586740"/>
             </a:xfrm>
             <a:prstGeom prst="rect">
               <a:avLst/>
@@ -1377,7 +1377,7 @@
             </a:ln>
           </p:spPr>
           <p:txBody>
-            <a:bodyPr wrap="none" lIns="0" tIns="0" rIns="0" bIns="0" anchor="t" anchorCtr="0">
+            <a:bodyPr wrap="square" lIns="0" tIns="0" rIns="0" bIns="0" anchor="t" anchorCtr="0">
               <a:spAutoFit/>
             </a:bodyPr>
             <a:lstStyle/>
@@ -1406,7 +1406,7 @@
           <p:spPr>
             <a:xfrm>
               <a:off x="601980" y="1390650"/>
-              <a:ext cx="6515712" cy="293370"/>
+              <a:ext cx="8335140" cy="293370"/>
             </a:xfrm>
             <a:prstGeom prst="rect">
               <a:avLst/>
@@ -1417,7 +1417,7 @@
             </a:ln>
           </p:spPr>
           <p:txBody>
-            <a:bodyPr wrap="none" lIns="0" tIns="0" rIns="0" bIns="0" anchor="t" anchorCtr="0">
+            <a:bodyPr wrap="square" lIns="0" tIns="0" rIns="0" bIns="0" anchor="t" anchorCtr="0">
               <a:spAutoFit/>
             </a:bodyPr>
             <a:lstStyle/>
@@ -1485,7 +1485,7 @@
           <p:spPr>
             <a:xfrm>
               <a:off x="984885" y="2298700"/>
-              <a:ext cx="1740324" cy="220028"/>
+              <a:ext cx="2365905" cy="220028"/>
             </a:xfrm>
             <a:prstGeom prst="rect">
               <a:avLst/>
@@ -1496,7 +1496,7 @@
             </a:ln>
           </p:spPr>
           <p:txBody>
-            <a:bodyPr wrap="none" lIns="0" tIns="0" rIns="0" bIns="0" anchor="t" anchorCtr="0">
+            <a:bodyPr wrap="square" lIns="0" tIns="0" rIns="0" bIns="0" anchor="t" anchorCtr="0">
               <a:spAutoFit/>
             </a:bodyPr>
             <a:lstStyle/>
@@ -1525,7 +1525,7 @@
           <p:spPr>
             <a:xfrm>
               <a:off x="973074" y="2844800"/>
-              <a:ext cx="4138020" cy="1246251"/>
+              <a:ext cx="4887577" cy="1246251"/>
             </a:xfrm>
             <a:prstGeom prst="rect">
               <a:avLst/>
@@ -1536,7 +1536,7 @@
             </a:ln>
           </p:spPr>
           <p:txBody>
-            <a:bodyPr wrap="none" lIns="0" tIns="0" rIns="0" bIns="0" anchor="t" anchorCtr="0">
+            <a:bodyPr wrap="square" lIns="0" tIns="0" rIns="0" bIns="0" anchor="t" anchorCtr="0">
               <a:spAutoFit/>
             </a:bodyPr>
             <a:lstStyle/>
@@ -1626,7 +1626,7 @@
           <p:spPr>
             <a:xfrm>
               <a:off x="983361" y="4559300"/>
-              <a:ext cx="3904268" cy="545402"/>
+              <a:ext cx="5070835" cy="545402"/>
             </a:xfrm>
             <a:prstGeom prst="rect">
               <a:avLst/>
@@ -1637,7 +1637,7 @@
             </a:ln>
           </p:spPr>
           <p:txBody>
-            <a:bodyPr wrap="none" lIns="0" tIns="0" rIns="0" bIns="0" anchor="t" anchorCtr="0">
+            <a:bodyPr wrap="square" lIns="0" tIns="0" rIns="0" bIns="0" anchor="t" anchorCtr="0">
               <a:spAutoFit/>
             </a:bodyPr>
             <a:lstStyle/>
@@ -1691,7 +1691,7 @@
           <p:spPr>
             <a:xfrm>
               <a:off x="984504" y="5562600"/>
-              <a:ext cx="3447304" cy="234696"/>
+              <a:ext cx="4499630" cy="234696"/>
             </a:xfrm>
             <a:prstGeom prst="rect">
               <a:avLst/>
@@ -1702,7 +1702,7 @@
             </a:ln>
           </p:spPr>
           <p:txBody>
-            <a:bodyPr wrap="none" lIns="0" tIns="0" rIns="0" bIns="0" anchor="t" anchorCtr="0">
+            <a:bodyPr wrap="square" lIns="0" tIns="0" rIns="0" bIns="0" anchor="t" anchorCtr="0">
               <a:spAutoFit/>
             </a:bodyPr>
             <a:lstStyle/>
@@ -1772,7 +1772,7 @@
           <p:spPr>
             <a:xfrm>
               <a:off x="7233285" y="2260600"/>
-              <a:ext cx="1348905" cy="220028"/>
+              <a:ext cx="1876631" cy="220028"/>
             </a:xfrm>
             <a:prstGeom prst="rect">
               <a:avLst/>
@@ -1783,7 +1783,7 @@
             </a:ln>
           </p:spPr>
           <p:txBody>
-            <a:bodyPr wrap="none" lIns="0" tIns="0" rIns="0" bIns="0" anchor="t" anchorCtr="0">
+            <a:bodyPr wrap="square" lIns="0" tIns="0" rIns="0" bIns="0" anchor="t" anchorCtr="0">
               <a:spAutoFit/>
             </a:bodyPr>
             <a:lstStyle/>
@@ -1812,7 +1812,7 @@
           <p:spPr>
             <a:xfrm>
               <a:off x="7229856" y="2565400"/>
-              <a:ext cx="3200879" cy="352044"/>
+              <a:ext cx="3801356" cy="352044"/>
             </a:xfrm>
             <a:prstGeom prst="rect">
               <a:avLst/>
@@ -1823,7 +1823,7 @@
             </a:ln>
           </p:spPr>
           <p:txBody>
-            <a:bodyPr wrap="none" lIns="0" tIns="0" rIns="0" bIns="0" anchor="t" anchorCtr="0">
+            <a:bodyPr wrap="square" lIns="0" tIns="0" rIns="0" bIns="0" anchor="t" anchorCtr="0">
               <a:spAutoFit/>
             </a:bodyPr>
             <a:lstStyle/>
@@ -1852,7 +1852,7 @@
           <p:spPr>
             <a:xfrm>
               <a:off x="7232142" y="3009900"/>
-              <a:ext cx="2996877" cy="521208"/>
+              <a:ext cx="3936596" cy="521208"/>
             </a:xfrm>
             <a:prstGeom prst="rect">
               <a:avLst/>
@@ -1863,7 +1863,7 @@
             </a:ln>
           </p:spPr>
           <p:txBody>
-            <a:bodyPr wrap="none" lIns="0" tIns="0" rIns="0" bIns="0" anchor="t" anchorCtr="0">
+            <a:bodyPr wrap="square" lIns="0" tIns="0" rIns="0" bIns="0" anchor="t" anchorCtr="0">
               <a:spAutoFit/>
             </a:bodyPr>
             <a:lstStyle/>
@@ -1958,7 +1958,7 @@
           <p:spPr>
             <a:xfrm>
               <a:off x="7233285" y="4508500"/>
-              <a:ext cx="1476404" cy="220028"/>
+              <a:ext cx="2036005" cy="220028"/>
             </a:xfrm>
             <a:prstGeom prst="rect">
               <a:avLst/>
@@ -1969,7 +1969,7 @@
             </a:ln>
           </p:spPr>
           <p:txBody>
-            <a:bodyPr wrap="none" lIns="0" tIns="0" rIns="0" bIns="0" anchor="t" anchorCtr="0">
+            <a:bodyPr wrap="square" lIns="0" tIns="0" rIns="0" bIns="0" anchor="t" anchorCtr="0">
               <a:spAutoFit/>
             </a:bodyPr>
             <a:lstStyle/>
@@ -1998,7 +1998,7 @@
           <p:spPr>
             <a:xfrm>
               <a:off x="7229856" y="4813300"/>
-              <a:ext cx="3291125" cy="352044"/>
+              <a:ext cx="3988355" cy="352044"/>
             </a:xfrm>
             <a:prstGeom prst="rect">
               <a:avLst/>
@@ -2009,7 +2009,7 @@
             </a:ln>
           </p:spPr>
           <p:txBody>
-            <a:bodyPr wrap="none" lIns="0" tIns="0" rIns="0" bIns="0" anchor="t" anchorCtr="0">
+            <a:bodyPr wrap="square" lIns="0" tIns="0" rIns="0" bIns="0" anchor="t" anchorCtr="0">
               <a:spAutoFit/>
             </a:bodyPr>
             <a:lstStyle/>
@@ -2038,7 +2038,7 @@
           <p:spPr>
             <a:xfrm>
               <a:off x="7232142" y="5257800"/>
-              <a:ext cx="2825325" cy="521208"/>
+              <a:ext cx="3722156" cy="521208"/>
             </a:xfrm>
             <a:prstGeom prst="rect">
               <a:avLst/>
@@ -2049,7 +2049,7 @@
             </a:ln>
           </p:spPr>
           <p:txBody>
-            <a:bodyPr wrap="none" lIns="0" tIns="0" rIns="0" bIns="0" anchor="t" anchorCtr="0">
+            <a:bodyPr wrap="square" lIns="0" tIns="0" rIns="0" bIns="0" anchor="t" anchorCtr="0">
               <a:spAutoFit/>
             </a:bodyPr>
             <a:lstStyle/>
@@ -2118,7 +2118,7 @@
           <p:spPr>
             <a:xfrm>
               <a:off x="603123" y="6419850"/>
-              <a:ext cx="547229" cy="250317"/>
+              <a:ext cx="839435" cy="250317"/>
             </a:xfrm>
             <a:prstGeom prst="rect">
               <a:avLst/>
@@ -2129,7 +2129,7 @@
             </a:ln>
           </p:spPr>
           <p:txBody>
-            <a:bodyPr wrap="none" lIns="0" tIns="0" rIns="0" bIns="0" anchor="t" anchorCtr="0">
+            <a:bodyPr wrap="square" lIns="0" tIns="0" rIns="0" bIns="0" anchor="t" anchorCtr="0">
               <a:spAutoFit/>
             </a:bodyPr>
             <a:lstStyle/>
@@ -2158,7 +2158,7 @@
           <p:spPr>
             <a:xfrm>
               <a:off x="1195197" y="6435725"/>
-              <a:ext cx="2013363" cy="191643"/>
+              <a:ext cx="2707203" cy="191643"/>
             </a:xfrm>
             <a:prstGeom prst="rect">
               <a:avLst/>
@@ -2169,7 +2169,7 @@
             </a:ln>
           </p:spPr>
           <p:txBody>
-            <a:bodyPr wrap="none" lIns="0" tIns="0" rIns="0" bIns="0" anchor="t" anchorCtr="0">
+            <a:bodyPr wrap="square" lIns="0" tIns="0" rIns="0" bIns="0" anchor="t" anchorCtr="0">
               <a:spAutoFit/>
             </a:bodyPr>
             <a:lstStyle/>
@@ -2191,22 +2191,34 @@
         </p:sp>
         <p:sp>
           <p:nvSpPr>
-            <p:cNvPr id="25" name="Rectangle 25"/>
+            <p:cNvPr id="25" name="Line 25"/>
             <p:cNvSpPr/>
             <p:nvPr/>
           </p:nvSpPr>
           <p:spPr>
             <a:xfrm>
-              <a:off x="11220450" y="6419850"/>
-              <a:ext cx="104775" cy="171450"/>
-            </a:xfrm>
-            <a:prstGeom prst="roundRect">
-              <a:avLst>
-                <a:gd name="adj" fmla="val 18182"/>
-              </a:avLst>
-            </a:prstGeom>
-            <a:noFill/>
-            <a:ln w="14288">
+              <a:off x="11068050" y="6515100"/>
+              <a:ext cx="190500" cy="9525"/>
+            </a:xfrm>
+            <a:custGeom>
+              <a:avLst/>
+              <a:gdLst/>
+              <a:ahLst/>
+              <a:cxnLst/>
+              <a:rect l="l" t="t" r="r" b="b"/>
+              <a:pathLst>
+                <a:path w="190500" h="9525">
+                  <a:moveTo>
+                    <a:pt x="0" y="0"/>
+                  </a:moveTo>
+                  <a:lnTo>
+                    <a:pt x="190500" y="0"/>
+                  </a:lnTo>
+                </a:path>
+              </a:pathLst>
+            </a:custGeom>
+            <a:noFill/>
+            <a:ln w="19050">
               <a:solidFill>
                 <a:srgbClr val="A8743A"/>
               </a:solidFill>
@@ -2221,8 +2233,8 @@
           </p:nvSpPr>
           <p:spPr>
             <a:xfrm>
-              <a:off x="11385936" y="6419850"/>
-              <a:ext cx="202941" cy="250317"/>
+              <a:off x="11154601" y="6419850"/>
+              <a:ext cx="434276" cy="250317"/>
             </a:xfrm>
             <a:prstGeom prst="rect">
               <a:avLst/>
@@ -2233,7 +2245,7 @@
             </a:ln>
           </p:spPr>
           <p:txBody>
-            <a:bodyPr wrap="none" lIns="0" tIns="0" rIns="0" bIns="0" anchor="t" anchorCtr="0">
+            <a:bodyPr wrap="square" lIns="0" tIns="0" rIns="0" bIns="0" anchor="t" anchorCtr="0">
               <a:spAutoFit/>
             </a:bodyPr>
             <a:lstStyle/>
@@ -2299,9 +2311,9 @@
         <p:grpSpPr>
           <a:xfrm>
             <a:off x="594360" y="565150"/>
-            <a:ext cx="8024652" cy="1118870"/>
+            <a:ext cx="7422213" cy="1118870"/>
             <a:chOff x="594360" y="565150"/>
-            <a:chExt cx="8024652" cy="1118870"/>
+            <a:chExt cx="7422213" cy="1118870"/>
           </a:xfrm>
         </p:grpSpPr>
         <p:sp>
@@ -2313,7 +2325,7 @@
           <p:spPr>
             <a:xfrm>
               <a:off x="603885" y="565150"/>
-              <a:ext cx="1299508" cy="220028"/>
+              <a:ext cx="1814885" cy="220028"/>
             </a:xfrm>
             <a:prstGeom prst="rect">
               <a:avLst/>
@@ -2324,7 +2336,7 @@
             </a:ln>
           </p:spPr>
           <p:txBody>
-            <a:bodyPr wrap="none" lIns="0" tIns="0" rIns="0" bIns="0" anchor="t" anchorCtr="0">
+            <a:bodyPr wrap="square" lIns="0" tIns="0" rIns="0" bIns="0" anchor="t" anchorCtr="0">
               <a:spAutoFit/>
             </a:bodyPr>
             <a:lstStyle/>
@@ -2353,7 +2365,7 @@
           <p:spPr>
             <a:xfrm>
               <a:off x="594360" y="850900"/>
-              <a:ext cx="8024652" cy="586740"/>
+              <a:ext cx="9468266" cy="586740"/>
             </a:xfrm>
             <a:prstGeom prst="rect">
               <a:avLst/>
@@ -2364,7 +2376,7 @@
             </a:ln>
           </p:spPr>
           <p:txBody>
-            <a:bodyPr wrap="none" lIns="0" tIns="0" rIns="0" bIns="0" anchor="t" anchorCtr="0">
+            <a:bodyPr wrap="square" lIns="0" tIns="0" rIns="0" bIns="0" anchor="t" anchorCtr="0">
               <a:spAutoFit/>
             </a:bodyPr>
             <a:lstStyle/>
@@ -2393,7 +2405,7 @@
           <p:spPr>
             <a:xfrm>
               <a:off x="601980" y="1390650"/>
-              <a:ext cx="4450627" cy="293370"/>
+              <a:ext cx="5753783" cy="293370"/>
             </a:xfrm>
             <a:prstGeom prst="rect">
               <a:avLst/>
@@ -2404,7 +2416,7 @@
             </a:ln>
           </p:spPr>
           <p:txBody>
-            <a:bodyPr wrap="none" lIns="0" tIns="0" rIns="0" bIns="0" anchor="t" anchorCtr="0">
+            <a:bodyPr wrap="square" lIns="0" tIns="0" rIns="0" bIns="0" anchor="t" anchorCtr="0">
               <a:spAutoFit/>
             </a:bodyPr>
             <a:lstStyle/>
@@ -2470,7 +2482,7 @@
           <p:spPr>
             <a:xfrm>
               <a:off x="829056" y="2241550"/>
-              <a:ext cx="917358" cy="352044"/>
+              <a:ext cx="1252361" cy="352044"/>
             </a:xfrm>
             <a:prstGeom prst="rect">
               <a:avLst/>
@@ -2481,7 +2493,7 @@
             </a:ln>
           </p:spPr>
           <p:txBody>
-            <a:bodyPr wrap="none" lIns="0" tIns="0" rIns="0" bIns="0" anchor="t" anchorCtr="0">
+            <a:bodyPr wrap="square" lIns="0" tIns="0" rIns="0" bIns="0" anchor="t" anchorCtr="0">
               <a:spAutoFit/>
             </a:bodyPr>
             <a:lstStyle/>
@@ -2510,7 +2522,7 @@
           <p:spPr>
             <a:xfrm>
               <a:off x="600456" y="2965450"/>
-              <a:ext cx="853831" cy="352044"/>
+              <a:ext cx="1239087" cy="352044"/>
             </a:xfrm>
             <a:prstGeom prst="rect">
               <a:avLst/>
@@ -2521,7 +2533,7 @@
             </a:ln>
           </p:spPr>
           <p:txBody>
-            <a:bodyPr wrap="none" lIns="0" tIns="0" rIns="0" bIns="0" anchor="t" anchorCtr="0">
+            <a:bodyPr wrap="square" lIns="0" tIns="0" rIns="0" bIns="0" anchor="t" anchorCtr="0">
               <a:spAutoFit/>
             </a:bodyPr>
             <a:lstStyle/>
@@ -2550,7 +2562,7 @@
           <p:spPr>
             <a:xfrm>
               <a:off x="602742" y="3333750"/>
-              <a:ext cx="2224735" cy="521208"/>
+              <a:ext cx="2971418" cy="521208"/>
             </a:xfrm>
             <a:prstGeom prst="rect">
               <a:avLst/>
@@ -2561,7 +2573,7 @@
             </a:ln>
           </p:spPr>
           <p:txBody>
-            <a:bodyPr wrap="none" lIns="0" tIns="0" rIns="0" bIns="0" anchor="t" anchorCtr="0">
+            <a:bodyPr wrap="square" lIns="0" tIns="0" rIns="0" bIns="0" anchor="t" anchorCtr="0">
               <a:spAutoFit/>
             </a:bodyPr>
             <a:lstStyle/>
@@ -2615,7 +2627,7 @@
           <p:spPr>
             <a:xfrm>
               <a:off x="604266" y="4349750"/>
-              <a:ext cx="1222028" cy="205359"/>
+              <a:ext cx="1718035" cy="205359"/>
             </a:xfrm>
             <a:prstGeom prst="rect">
               <a:avLst/>
@@ -2626,7 +2638,7 @@
             </a:ln>
           </p:spPr>
           <p:txBody>
-            <a:bodyPr wrap="none" lIns="0" tIns="0" rIns="0" bIns="0" anchor="t" anchorCtr="0">
+            <a:bodyPr wrap="square" lIns="0" tIns="0" rIns="0" bIns="0" anchor="t" anchorCtr="0">
               <a:spAutoFit/>
             </a:bodyPr>
             <a:lstStyle/>
@@ -2655,7 +2667,7 @@
           <p:spPr>
             <a:xfrm>
               <a:off x="602742" y="4572000"/>
-              <a:ext cx="1977539" cy="521208"/>
+              <a:ext cx="2662423" cy="521208"/>
             </a:xfrm>
             <a:prstGeom prst="rect">
               <a:avLst/>
@@ -2666,7 +2678,7 @@
             </a:ln>
           </p:spPr>
           <p:txBody>
-            <a:bodyPr wrap="none" lIns="0" tIns="0" rIns="0" bIns="0" anchor="t" anchorCtr="0">
+            <a:bodyPr wrap="square" lIns="0" tIns="0" rIns="0" bIns="0" anchor="t" anchorCtr="0">
               <a:spAutoFit/>
             </a:bodyPr>
             <a:lstStyle/>
@@ -2757,7 +2769,7 @@
           <p:spPr>
             <a:xfrm>
               <a:off x="3610356" y="2241550"/>
-              <a:ext cx="1471234" cy="352044"/>
+              <a:ext cx="1944477" cy="352044"/>
             </a:xfrm>
             <a:prstGeom prst="rect">
               <a:avLst/>
@@ -2768,7 +2780,7 @@
             </a:ln>
           </p:spPr>
           <p:txBody>
-            <a:bodyPr wrap="none" lIns="0" tIns="0" rIns="0" bIns="0" anchor="t" anchorCtr="0">
+            <a:bodyPr wrap="square" lIns="0" tIns="0" rIns="0" bIns="0" anchor="t" anchorCtr="0">
               <a:spAutoFit/>
             </a:bodyPr>
             <a:lstStyle/>
@@ -2797,7 +2809,7 @@
           <p:spPr>
             <a:xfrm>
               <a:off x="3610356" y="2965450"/>
-              <a:ext cx="1095506" cy="352044"/>
+              <a:ext cx="1417527" cy="352044"/>
             </a:xfrm>
             <a:prstGeom prst="rect">
               <a:avLst/>
@@ -2808,7 +2820,7 @@
             </a:ln>
           </p:spPr>
           <p:txBody>
-            <a:bodyPr wrap="none" lIns="0" tIns="0" rIns="0" bIns="0" anchor="t" anchorCtr="0">
+            <a:bodyPr wrap="square" lIns="0" tIns="0" rIns="0" bIns="0" anchor="t" anchorCtr="0">
               <a:spAutoFit/>
             </a:bodyPr>
             <a:lstStyle/>
@@ -2837,7 +2849,7 @@
           <p:spPr>
             <a:xfrm>
               <a:off x="3612642" y="3333750"/>
-              <a:ext cx="4426496" cy="521208"/>
+              <a:ext cx="5723620" cy="521208"/>
             </a:xfrm>
             <a:prstGeom prst="rect">
               <a:avLst/>
@@ -2848,7 +2860,7 @@
             </a:ln>
           </p:spPr>
           <p:txBody>
-            <a:bodyPr wrap="none" lIns="0" tIns="0" rIns="0" bIns="0" anchor="t" anchorCtr="0">
+            <a:bodyPr wrap="square" lIns="0" tIns="0" rIns="0" bIns="0" anchor="t" anchorCtr="0">
               <a:spAutoFit/>
             </a:bodyPr>
             <a:lstStyle/>
@@ -2902,7 +2914,7 @@
           <p:spPr>
             <a:xfrm>
               <a:off x="3614166" y="4349750"/>
-              <a:ext cx="1222028" cy="205359"/>
+              <a:ext cx="1718035" cy="205359"/>
             </a:xfrm>
             <a:prstGeom prst="rect">
               <a:avLst/>
@@ -2913,7 +2925,7 @@
             </a:ln>
           </p:spPr>
           <p:txBody>
-            <a:bodyPr wrap="none" lIns="0" tIns="0" rIns="0" bIns="0" anchor="t" anchorCtr="0">
+            <a:bodyPr wrap="square" lIns="0" tIns="0" rIns="0" bIns="0" anchor="t" anchorCtr="0">
               <a:spAutoFit/>
             </a:bodyPr>
             <a:lstStyle/>
@@ -2942,7 +2954,7 @@
           <p:spPr>
             <a:xfrm>
               <a:off x="3612642" y="4597400"/>
-              <a:ext cx="3426359" cy="264033"/>
+              <a:ext cx="4473448" cy="264033"/>
             </a:xfrm>
             <a:prstGeom prst="rect">
               <a:avLst/>
@@ -2953,7 +2965,7 @@
             </a:ln>
           </p:spPr>
           <p:txBody>
-            <a:bodyPr wrap="none" lIns="0" tIns="0" rIns="0" bIns="0" anchor="t" anchorCtr="0">
+            <a:bodyPr wrap="square" lIns="0" tIns="0" rIns="0" bIns="0" anchor="t" anchorCtr="0">
               <a:spAutoFit/>
             </a:bodyPr>
             <a:lstStyle/>
@@ -3019,7 +3031,7 @@
           <p:spPr>
             <a:xfrm>
               <a:off x="9096756" y="2241550"/>
-              <a:ext cx="900634" cy="352044"/>
+              <a:ext cx="1252361" cy="352044"/>
             </a:xfrm>
             <a:prstGeom prst="rect">
               <a:avLst/>
@@ -3030,7 +3042,7 @@
             </a:ln>
           </p:spPr>
           <p:txBody>
-            <a:bodyPr wrap="none" lIns="0" tIns="0" rIns="0" bIns="0" anchor="t" anchorCtr="0">
+            <a:bodyPr wrap="square" lIns="0" tIns="0" rIns="0" bIns="0" anchor="t" anchorCtr="0">
               <a:spAutoFit/>
             </a:bodyPr>
             <a:lstStyle/>
@@ -3059,7 +3071,7 @@
           <p:spPr>
             <a:xfrm>
               <a:off x="9096756" y="2965450"/>
-              <a:ext cx="1684007" cy="352044"/>
+              <a:ext cx="2137731" cy="352044"/>
             </a:xfrm>
             <a:prstGeom prst="rect">
               <a:avLst/>
@@ -3070,7 +3082,7 @@
             </a:ln>
           </p:spPr>
           <p:txBody>
-            <a:bodyPr wrap="none" lIns="0" tIns="0" rIns="0" bIns="0" anchor="t" anchorCtr="0">
+            <a:bodyPr wrap="square" lIns="0" tIns="0" rIns="0" bIns="0" anchor="t" anchorCtr="0">
               <a:spAutoFit/>
             </a:bodyPr>
             <a:lstStyle/>
@@ -3099,7 +3111,7 @@
           <p:spPr>
             <a:xfrm>
               <a:off x="9099042" y="3333750"/>
-              <a:ext cx="2005656" cy="521208"/>
+              <a:ext cx="2697570" cy="521208"/>
             </a:xfrm>
             <a:prstGeom prst="rect">
               <a:avLst/>
@@ -3110,7 +3122,7 @@
             </a:ln>
           </p:spPr>
           <p:txBody>
-            <a:bodyPr wrap="none" lIns="0" tIns="0" rIns="0" bIns="0" anchor="t" anchorCtr="0">
+            <a:bodyPr wrap="square" lIns="0" tIns="0" rIns="0" bIns="0" anchor="t" anchorCtr="0">
               <a:spAutoFit/>
             </a:bodyPr>
             <a:lstStyle/>
@@ -3164,7 +3176,7 @@
           <p:spPr>
             <a:xfrm>
               <a:off x="9100566" y="4349750"/>
-              <a:ext cx="1222028" cy="205359"/>
+              <a:ext cx="1718035" cy="205359"/>
             </a:xfrm>
             <a:prstGeom prst="rect">
               <a:avLst/>
@@ -3175,7 +3187,7 @@
             </a:ln>
           </p:spPr>
           <p:txBody>
-            <a:bodyPr wrap="none" lIns="0" tIns="0" rIns="0" bIns="0" anchor="t" anchorCtr="0">
+            <a:bodyPr wrap="square" lIns="0" tIns="0" rIns="0" bIns="0" anchor="t" anchorCtr="0">
               <a:spAutoFit/>
             </a:bodyPr>
             <a:lstStyle/>
@@ -3204,7 +3216,7 @@
           <p:spPr>
             <a:xfrm>
               <a:off x="9099042" y="4572000"/>
-              <a:ext cx="1786543" cy="521208"/>
+              <a:ext cx="2423678" cy="521208"/>
             </a:xfrm>
             <a:prstGeom prst="rect">
               <a:avLst/>
@@ -3215,7 +3227,7 @@
             </a:ln>
           </p:spPr>
           <p:txBody>
-            <a:bodyPr wrap="none" lIns="0" tIns="0" rIns="0" bIns="0" anchor="t" anchorCtr="0">
+            <a:bodyPr wrap="square" lIns="0" tIns="0" rIns="0" bIns="0" anchor="t" anchorCtr="0">
               <a:spAutoFit/>
             </a:bodyPr>
             <a:lstStyle/>
@@ -3306,7 +3318,7 @@
           <p:spPr>
             <a:xfrm>
               <a:off x="603123" y="6419850"/>
-              <a:ext cx="547229" cy="250317"/>
+              <a:ext cx="839435" cy="250317"/>
             </a:xfrm>
             <a:prstGeom prst="rect">
               <a:avLst/>
@@ -3317,7 +3329,7 @@
             </a:ln>
           </p:spPr>
           <p:txBody>
-            <a:bodyPr wrap="none" lIns="0" tIns="0" rIns="0" bIns="0" anchor="t" anchorCtr="0">
+            <a:bodyPr wrap="square" lIns="0" tIns="0" rIns="0" bIns="0" anchor="t" anchorCtr="0">
               <a:spAutoFit/>
             </a:bodyPr>
             <a:lstStyle/>
@@ -3346,7 +3358,7 @@
           <p:spPr>
             <a:xfrm>
               <a:off x="1195197" y="6435725"/>
-              <a:ext cx="2013363" cy="191643"/>
+              <a:ext cx="2707203" cy="191643"/>
             </a:xfrm>
             <a:prstGeom prst="rect">
               <a:avLst/>
@@ -3357,7 +3369,7 @@
             </a:ln>
           </p:spPr>
           <p:txBody>
-            <a:bodyPr wrap="none" lIns="0" tIns="0" rIns="0" bIns="0" anchor="t" anchorCtr="0">
+            <a:bodyPr wrap="square" lIns="0" tIns="0" rIns="0" bIns="0" anchor="t" anchorCtr="0">
               <a:spAutoFit/>
             </a:bodyPr>
             <a:lstStyle/>
@@ -3379,22 +3391,34 @@
         </p:sp>
         <p:sp>
           <p:nvSpPr>
-            <p:cNvPr id="30" name="Rectangle 30"/>
+            <p:cNvPr id="30" name="Line 30"/>
             <p:cNvSpPr/>
             <p:nvPr/>
           </p:nvSpPr>
           <p:spPr>
             <a:xfrm>
-              <a:off x="11220450" y="6419850"/>
-              <a:ext cx="104775" cy="171450"/>
-            </a:xfrm>
-            <a:prstGeom prst="roundRect">
-              <a:avLst>
-                <a:gd name="adj" fmla="val 18182"/>
-              </a:avLst>
-            </a:prstGeom>
-            <a:noFill/>
-            <a:ln w="14288">
+              <a:off x="11068050" y="6515100"/>
+              <a:ext cx="190500" cy="9525"/>
+            </a:xfrm>
+            <a:custGeom>
+              <a:avLst/>
+              <a:gdLst/>
+              <a:ahLst/>
+              <a:cxnLst/>
+              <a:rect l="l" t="t" r="r" b="b"/>
+              <a:pathLst>
+                <a:path w="190500" h="9525">
+                  <a:moveTo>
+                    <a:pt x="0" y="0"/>
+                  </a:moveTo>
+                  <a:lnTo>
+                    <a:pt x="190500" y="0"/>
+                  </a:lnTo>
+                </a:path>
+              </a:pathLst>
+            </a:custGeom>
+            <a:noFill/>
+            <a:ln w="19050">
               <a:solidFill>
                 <a:srgbClr val="A8743A"/>
               </a:solidFill>
@@ -3409,8 +3433,8 @@
           </p:nvSpPr>
           <p:spPr>
             <a:xfrm>
-              <a:off x="11419454" y="6419850"/>
-              <a:ext cx="169423" cy="250317"/>
+              <a:off x="11154601" y="6419850"/>
+              <a:ext cx="434276" cy="250317"/>
             </a:xfrm>
             <a:prstGeom prst="rect">
               <a:avLst/>
@@ -3421,7 +3445,7 @@
             </a:ln>
           </p:spPr>
           <p:txBody>
-            <a:bodyPr wrap="none" lIns="0" tIns="0" rIns="0" bIns="0" anchor="t" anchorCtr="0">
+            <a:bodyPr wrap="square" lIns="0" tIns="0" rIns="0" bIns="0" anchor="t" anchorCtr="0">
               <a:spAutoFit/>
             </a:bodyPr>
             <a:lstStyle/>
@@ -3501,7 +3525,7 @@
           <p:spPr>
             <a:xfrm>
               <a:off x="603885" y="1441450"/>
-              <a:ext cx="1643567" cy="220028"/>
+              <a:ext cx="2244958" cy="220028"/>
             </a:xfrm>
             <a:prstGeom prst="rect">
               <a:avLst/>
@@ -3512,7 +3536,7 @@
             </a:ln>
           </p:spPr>
           <p:txBody>
-            <a:bodyPr wrap="none" lIns="0" tIns="0" rIns="0" bIns="0" anchor="t" anchorCtr="0">
+            <a:bodyPr wrap="square" lIns="0" tIns="0" rIns="0" bIns="0" anchor="t" anchorCtr="0">
               <a:spAutoFit/>
             </a:bodyPr>
             <a:lstStyle/>
@@ -3563,7 +3587,7 @@
           <p:spPr>
             <a:xfrm>
               <a:off x="590550" y="2108200"/>
-              <a:ext cx="4134020" cy="1533525"/>
+              <a:ext cx="4916410" cy="1533525"/>
             </a:xfrm>
             <a:prstGeom prst="rect">
               <a:avLst/>
@@ -3574,7 +3598,7 @@
             </a:ln>
           </p:spPr>
           <p:txBody>
-            <a:bodyPr wrap="none" lIns="0" tIns="0" rIns="0" bIns="0" anchor="t" anchorCtr="0">
+            <a:bodyPr wrap="square" lIns="0" tIns="0" rIns="0" bIns="0" anchor="t" anchorCtr="0">
               <a:spAutoFit/>
             </a:bodyPr>
             <a:lstStyle/>
@@ -3628,7 +3652,7 @@
           <p:spPr>
             <a:xfrm>
               <a:off x="601218" y="3771900"/>
-              <a:ext cx="4734196" cy="627507"/>
+              <a:ext cx="6108245" cy="627507"/>
             </a:xfrm>
             <a:prstGeom prst="rect">
               <a:avLst/>
@@ -3639,7 +3663,7 @@
             </a:ln>
           </p:spPr>
           <p:txBody>
-            <a:bodyPr wrap="none" lIns="0" tIns="0" rIns="0" bIns="0" anchor="t" anchorCtr="0">
+            <a:bodyPr wrap="square" lIns="0" tIns="0" rIns="0" bIns="0" anchor="t" anchorCtr="0">
               <a:spAutoFit/>
             </a:bodyPr>
             <a:lstStyle/>
@@ -3744,7 +3768,7 @@
           <p:spPr>
             <a:xfrm>
               <a:off x="598170" y="5397500"/>
-              <a:ext cx="2969276" cy="440055"/>
+              <a:ext cx="3597297" cy="440055"/>
             </a:xfrm>
             <a:prstGeom prst="rect">
               <a:avLst/>
@@ -3755,7 +3779,7 @@
             </a:ln>
           </p:spPr>
           <p:txBody>
-            <a:bodyPr wrap="none" lIns="0" tIns="0" rIns="0" bIns="0" anchor="t" anchorCtr="0">
+            <a:bodyPr wrap="square" lIns="0" tIns="0" rIns="0" bIns="0" anchor="t" anchorCtr="0">
               <a:spAutoFit/>
             </a:bodyPr>
             <a:lstStyle/>
@@ -3784,7 +3808,7 @@
           <p:spPr>
             <a:xfrm>
               <a:off x="603123" y="5867400"/>
-              <a:ext cx="2428587" cy="250317"/>
+              <a:ext cx="3226233" cy="250317"/>
             </a:xfrm>
             <a:prstGeom prst="rect">
               <a:avLst/>
@@ -3795,7 +3819,7 @@
             </a:ln>
           </p:spPr>
           <p:txBody>
-            <a:bodyPr wrap="none" lIns="0" tIns="0" rIns="0" bIns="0" anchor="t" anchorCtr="0">
+            <a:bodyPr wrap="square" lIns="0" tIns="0" rIns="0" bIns="0" anchor="t" anchorCtr="0">
               <a:spAutoFit/>
             </a:bodyPr>
             <a:lstStyle/>
@@ -4079,9 +4103,9 @@
         <p:grpSpPr>
           <a:xfrm>
             <a:off x="594360" y="565150"/>
-            <a:ext cx="8866672" cy="1118870"/>
+            <a:ext cx="7980134" cy="1118870"/>
             <a:chOff x="594360" y="565150"/>
-            <a:chExt cx="8866672" cy="1118870"/>
+            <a:chExt cx="7980134" cy="1118870"/>
           </a:xfrm>
         </p:grpSpPr>
         <p:sp>
@@ -4093,7 +4117,7 @@
           <p:spPr>
             <a:xfrm>
               <a:off x="603885" y="565150"/>
-              <a:ext cx="1669687" cy="220028"/>
+              <a:ext cx="2277608" cy="220028"/>
             </a:xfrm>
             <a:prstGeom prst="rect">
               <a:avLst/>
@@ -4104,7 +4128,7 @@
             </a:ln>
           </p:spPr>
           <p:txBody>
-            <a:bodyPr wrap="none" lIns="0" tIns="0" rIns="0" bIns="0" anchor="t" anchorCtr="0">
+            <a:bodyPr wrap="square" lIns="0" tIns="0" rIns="0" bIns="0" anchor="t" anchorCtr="0">
               <a:spAutoFit/>
             </a:bodyPr>
             <a:lstStyle/>
@@ -4133,7 +4157,7 @@
           <p:spPr>
             <a:xfrm>
               <a:off x="594360" y="850900"/>
-              <a:ext cx="8866672" cy="586740"/>
+              <a:ext cx="10165667" cy="586740"/>
             </a:xfrm>
             <a:prstGeom prst="rect">
               <a:avLst/>
@@ -4144,7 +4168,7 @@
             </a:ln>
           </p:spPr>
           <p:txBody>
-            <a:bodyPr wrap="none" lIns="0" tIns="0" rIns="0" bIns="0" anchor="t" anchorCtr="0">
+            <a:bodyPr wrap="square" lIns="0" tIns="0" rIns="0" bIns="0" anchor="t" anchorCtr="0">
               <a:spAutoFit/>
             </a:bodyPr>
             <a:lstStyle/>
@@ -4173,7 +4197,7 @@
           <p:spPr>
             <a:xfrm>
               <a:off x="601980" y="1390650"/>
-              <a:ext cx="6059486" cy="293370"/>
+              <a:ext cx="7764857" cy="293370"/>
             </a:xfrm>
             <a:prstGeom prst="rect">
               <a:avLst/>
@@ -4184,7 +4208,7 @@
             </a:ln>
           </p:spPr>
           <p:txBody>
-            <a:bodyPr wrap="none" lIns="0" tIns="0" rIns="0" bIns="0" anchor="t" anchorCtr="0">
+            <a:bodyPr wrap="square" lIns="0" tIns="0" rIns="0" bIns="0" anchor="t" anchorCtr="0">
               <a:spAutoFit/>
             </a:bodyPr>
             <a:lstStyle/>
@@ -4228,7 +4252,7 @@
           <p:spPr>
             <a:xfrm>
               <a:off x="603885" y="2203450"/>
-              <a:ext cx="2900743" cy="220028"/>
+              <a:ext cx="3816428" cy="220028"/>
             </a:xfrm>
             <a:prstGeom prst="rect">
               <a:avLst/>
@@ -4239,7 +4263,7 @@
             </a:ln>
           </p:spPr>
           <p:txBody>
-            <a:bodyPr wrap="none" lIns="0" tIns="0" rIns="0" bIns="0" anchor="t" anchorCtr="0">
+            <a:bodyPr wrap="square" lIns="0" tIns="0" rIns="0" bIns="0" anchor="t" anchorCtr="0">
               <a:spAutoFit/>
             </a:bodyPr>
             <a:lstStyle/>
@@ -6173,7 +6197,7 @@
           <p:spPr>
             <a:xfrm>
               <a:off x="812673" y="4905375"/>
-              <a:ext cx="3136651" cy="250317"/>
+              <a:ext cx="4111313" cy="250317"/>
             </a:xfrm>
             <a:prstGeom prst="rect">
               <a:avLst/>
@@ -6184,7 +6208,7 @@
             </a:ln>
           </p:spPr>
           <p:txBody>
-            <a:bodyPr wrap="none" lIns="0" tIns="0" rIns="0" bIns="0" anchor="t" anchorCtr="0">
+            <a:bodyPr wrap="square" lIns="0" tIns="0" rIns="0" bIns="0" anchor="t" anchorCtr="0">
               <a:spAutoFit/>
             </a:bodyPr>
             <a:lstStyle/>
@@ -6213,7 +6237,7 @@
           <p:spPr>
             <a:xfrm>
               <a:off x="604647" y="5321300"/>
-              <a:ext cx="2639261" cy="191643"/>
+              <a:ext cx="3489576" cy="191643"/>
             </a:xfrm>
             <a:prstGeom prst="rect">
               <a:avLst/>
@@ -6224,7 +6248,7 @@
             </a:ln>
           </p:spPr>
           <p:txBody>
-            <a:bodyPr wrap="none" lIns="0" tIns="0" rIns="0" bIns="0" anchor="t" anchorCtr="0">
+            <a:bodyPr wrap="square" lIns="0" tIns="0" rIns="0" bIns="0" anchor="t" anchorCtr="0">
               <a:spAutoFit/>
             </a:bodyPr>
             <a:lstStyle/>
@@ -6290,7 +6314,7 @@
           <p:spPr>
             <a:xfrm>
               <a:off x="7574280" y="2279650"/>
-              <a:ext cx="3022587" cy="1179195"/>
+              <a:ext cx="3968733" cy="1179195"/>
             </a:xfrm>
             <a:prstGeom prst="rect">
               <a:avLst/>
@@ -6301,7 +6325,7 @@
             </a:ln>
           </p:spPr>
           <p:txBody>
-            <a:bodyPr wrap="none" lIns="0" tIns="0" rIns="0" bIns="0" anchor="t" anchorCtr="0">
+            <a:bodyPr wrap="square" lIns="0" tIns="0" rIns="0" bIns="0" anchor="t" anchorCtr="0">
               <a:spAutoFit/>
             </a:bodyPr>
             <a:lstStyle/>
@@ -6397,7 +6421,7 @@
           <p:spPr>
             <a:xfrm>
               <a:off x="7564374" y="4070350"/>
-              <a:ext cx="2218134" cy="1208151"/>
+              <a:ext cx="2713258" cy="1208151"/>
             </a:xfrm>
             <a:prstGeom prst="rect">
               <a:avLst/>
@@ -6408,7 +6432,7 @@
             </a:ln>
           </p:spPr>
           <p:txBody>
-            <a:bodyPr wrap="none" lIns="0" tIns="0" rIns="0" bIns="0" anchor="t" anchorCtr="0">
+            <a:bodyPr wrap="square" lIns="0" tIns="0" rIns="0" bIns="0" anchor="t" anchorCtr="0">
               <a:spAutoFit/>
             </a:bodyPr>
             <a:lstStyle/>
@@ -6462,7 +6486,7 @@
           <p:spPr>
             <a:xfrm>
               <a:off x="7575423" y="5619750"/>
-              <a:ext cx="2403263" cy="250317"/>
+              <a:ext cx="3194578" cy="250317"/>
             </a:xfrm>
             <a:prstGeom prst="rect">
               <a:avLst/>
@@ -6473,7 +6497,7 @@
             </a:ln>
           </p:spPr>
           <p:txBody>
-            <a:bodyPr wrap="none" lIns="0" tIns="0" rIns="0" bIns="0" anchor="t" anchorCtr="0">
+            <a:bodyPr wrap="square" lIns="0" tIns="0" rIns="0" bIns="0" anchor="t" anchorCtr="0">
               <a:spAutoFit/>
             </a:bodyPr>
             <a:lstStyle/>
@@ -6517,7 +6541,7 @@
           <p:spPr>
             <a:xfrm>
               <a:off x="603123" y="6419850"/>
-              <a:ext cx="547229" cy="250317"/>
+              <a:ext cx="839435" cy="250317"/>
             </a:xfrm>
             <a:prstGeom prst="rect">
               <a:avLst/>
@@ -6528,7 +6552,7 @@
             </a:ln>
           </p:spPr>
           <p:txBody>
-            <a:bodyPr wrap="none" lIns="0" tIns="0" rIns="0" bIns="0" anchor="t" anchorCtr="0">
+            <a:bodyPr wrap="square" lIns="0" tIns="0" rIns="0" bIns="0" anchor="t" anchorCtr="0">
               <a:spAutoFit/>
             </a:bodyPr>
             <a:lstStyle/>
@@ -6557,7 +6581,7 @@
           <p:spPr>
             <a:xfrm>
               <a:off x="1195197" y="6435725"/>
-              <a:ext cx="2013363" cy="191643"/>
+              <a:ext cx="2707203" cy="191643"/>
             </a:xfrm>
             <a:prstGeom prst="rect">
               <a:avLst/>
@@ -6568,7 +6592,7 @@
             </a:ln>
           </p:spPr>
           <p:txBody>
-            <a:bodyPr wrap="none" lIns="0" tIns="0" rIns="0" bIns="0" anchor="t" anchorCtr="0">
+            <a:bodyPr wrap="square" lIns="0" tIns="0" rIns="0" bIns="0" anchor="t" anchorCtr="0">
               <a:spAutoFit/>
             </a:bodyPr>
             <a:lstStyle/>
@@ -6590,22 +6614,34 @@
         </p:sp>
         <p:sp>
           <p:nvSpPr>
-            <p:cNvPr id="99" name="Rectangle 99"/>
+            <p:cNvPr id="99" name="Line 99"/>
             <p:cNvSpPr/>
             <p:nvPr/>
           </p:nvSpPr>
           <p:spPr>
             <a:xfrm>
-              <a:off x="11220450" y="6419850"/>
-              <a:ext cx="104775" cy="171450"/>
-            </a:xfrm>
-            <a:prstGeom prst="roundRect">
-              <a:avLst>
-                <a:gd name="adj" fmla="val 18182"/>
-              </a:avLst>
-            </a:prstGeom>
-            <a:noFill/>
-            <a:ln w="14288">
+              <a:off x="11068050" y="6515100"/>
+              <a:ext cx="190500" cy="9525"/>
+            </a:xfrm>
+            <a:custGeom>
+              <a:avLst/>
+              <a:gdLst/>
+              <a:ahLst/>
+              <a:cxnLst/>
+              <a:rect l="l" t="t" r="r" b="b"/>
+              <a:pathLst>
+                <a:path w="190500" h="9525">
+                  <a:moveTo>
+                    <a:pt x="0" y="0"/>
+                  </a:moveTo>
+                  <a:lnTo>
+                    <a:pt x="190500" y="0"/>
+                  </a:lnTo>
+                </a:path>
+              </a:pathLst>
+            </a:custGeom>
+            <a:noFill/>
+            <a:ln w="19050">
               <a:solidFill>
                 <a:srgbClr val="A8743A"/>
               </a:solidFill>
@@ -6620,8 +6656,8 @@
           </p:nvSpPr>
           <p:spPr>
             <a:xfrm>
-              <a:off x="11362467" y="6419850"/>
-              <a:ext cx="226410" cy="250317"/>
+              <a:off x="11154601" y="6419850"/>
+              <a:ext cx="434276" cy="250317"/>
             </a:xfrm>
             <a:prstGeom prst="rect">
               <a:avLst/>
@@ -6632,7 +6668,7 @@
             </a:ln>
           </p:spPr>
           <p:txBody>
-            <a:bodyPr wrap="none" lIns="0" tIns="0" rIns="0" bIns="0" anchor="t" anchorCtr="0">
+            <a:bodyPr wrap="square" lIns="0" tIns="0" rIns="0" bIns="0" anchor="t" anchorCtr="0">
               <a:spAutoFit/>
             </a:bodyPr>
             <a:lstStyle/>
@@ -6698,9 +6734,9 @@
         <p:grpSpPr>
           <a:xfrm>
             <a:off x="594360" y="565150"/>
-            <a:ext cx="9669558" cy="1118870"/>
+            <a:ext cx="8727719" cy="1118870"/>
             <a:chOff x="594360" y="565150"/>
-            <a:chExt cx="9669558" cy="1118870"/>
+            <a:chExt cx="8727719" cy="1118870"/>
           </a:xfrm>
         </p:grpSpPr>
         <p:sp>
@@ -6712,7 +6748,7 @@
           <p:spPr>
             <a:xfrm>
               <a:off x="603885" y="565150"/>
-              <a:ext cx="2606566" cy="220028"/>
+              <a:ext cx="3448707" cy="220028"/>
             </a:xfrm>
             <a:prstGeom prst="rect">
               <a:avLst/>
@@ -6723,7 +6759,7 @@
             </a:ln>
           </p:spPr>
           <p:txBody>
-            <a:bodyPr wrap="none" lIns="0" tIns="0" rIns="0" bIns="0" anchor="t" anchorCtr="0">
+            <a:bodyPr wrap="square" lIns="0" tIns="0" rIns="0" bIns="0" anchor="t" anchorCtr="0">
               <a:spAutoFit/>
             </a:bodyPr>
             <a:lstStyle/>
@@ -6752,7 +6788,7 @@
           <p:spPr>
             <a:xfrm>
               <a:off x="594360" y="850900"/>
-              <a:ext cx="9669558" cy="586740"/>
+              <a:ext cx="11100148" cy="586740"/>
             </a:xfrm>
             <a:prstGeom prst="rect">
               <a:avLst/>
@@ -6763,7 +6799,7 @@
             </a:ln>
           </p:spPr>
           <p:txBody>
-            <a:bodyPr wrap="none" lIns="0" tIns="0" rIns="0" bIns="0" anchor="t" anchorCtr="0">
+            <a:bodyPr wrap="square" lIns="0" tIns="0" rIns="0" bIns="0" anchor="t" anchorCtr="0">
               <a:spAutoFit/>
             </a:bodyPr>
             <a:lstStyle/>
@@ -6792,7 +6828,7 @@
           <p:spPr>
             <a:xfrm>
               <a:off x="601980" y="1390650"/>
-              <a:ext cx="7350900" cy="293370"/>
+              <a:ext cx="9379125" cy="293370"/>
             </a:xfrm>
             <a:prstGeom prst="rect">
               <a:avLst/>
@@ -6803,7 +6839,7 @@
             </a:ln>
           </p:spPr>
           <p:txBody>
-            <a:bodyPr wrap="none" lIns="0" tIns="0" rIns="0" bIns="0" anchor="t" anchorCtr="0">
+            <a:bodyPr wrap="square" lIns="0" tIns="0" rIns="0" bIns="0" anchor="t" anchorCtr="0">
               <a:spAutoFit/>
             </a:bodyPr>
             <a:lstStyle/>
@@ -6871,7 +6907,7 @@
           <p:spPr>
             <a:xfrm>
               <a:off x="946785" y="2279650"/>
-              <a:ext cx="1906811" cy="220028"/>
+              <a:ext cx="2574013" cy="220028"/>
             </a:xfrm>
             <a:prstGeom prst="rect">
               <a:avLst/>
@@ -6882,7 +6918,7 @@
             </a:ln>
           </p:spPr>
           <p:txBody>
-            <a:bodyPr wrap="none" lIns="0" tIns="0" rIns="0" bIns="0" anchor="t" anchorCtr="0">
+            <a:bodyPr wrap="square" lIns="0" tIns="0" rIns="0" bIns="0" anchor="t" anchorCtr="0">
               <a:spAutoFit/>
             </a:bodyPr>
             <a:lstStyle/>
@@ -6947,7 +6983,7 @@
             <p:spPr>
               <a:xfrm>
                 <a:off x="1325499" y="2828925"/>
-                <a:ext cx="2635106" cy="308991"/>
+                <a:ext cx="3484382" cy="308991"/>
               </a:xfrm>
               <a:prstGeom prst="rect">
                 <a:avLst/>
@@ -6958,7 +6994,7 @@
               </a:ln>
             </p:spPr>
             <p:txBody>
-              <a:bodyPr wrap="none" lIns="0" tIns="0" rIns="0" bIns="0" anchor="t" anchorCtr="0">
+              <a:bodyPr wrap="square" lIns="0" tIns="0" rIns="0" bIns="0" anchor="t" anchorCtr="0">
                 <a:spAutoFit/>
               </a:bodyPr>
               <a:lstStyle/>
@@ -7032,7 +7068,7 @@
             <p:spPr>
               <a:xfrm>
                 <a:off x="1325499" y="3590925"/>
-                <a:ext cx="2174565" cy="308991"/>
+                <a:ext cx="2908706" cy="308991"/>
               </a:xfrm>
               <a:prstGeom prst="rect">
                 <a:avLst/>
@@ -7043,7 +7079,7 @@
               </a:ln>
             </p:spPr>
             <p:txBody>
-              <a:bodyPr wrap="none" lIns="0" tIns="0" rIns="0" bIns="0" anchor="t" anchorCtr="0">
+              <a:bodyPr wrap="square" lIns="0" tIns="0" rIns="0" bIns="0" anchor="t" anchorCtr="0">
                 <a:spAutoFit/>
               </a:bodyPr>
               <a:lstStyle/>
@@ -7117,7 +7153,7 @@
             <p:spPr>
               <a:xfrm>
                 <a:off x="1325499" y="4352925"/>
-                <a:ext cx="2068473" cy="308991"/>
+                <a:ext cx="2776091" cy="308991"/>
               </a:xfrm>
               <a:prstGeom prst="rect">
                 <a:avLst/>
@@ -7128,7 +7164,7 @@
               </a:ln>
             </p:spPr>
             <p:txBody>
-              <a:bodyPr wrap="none" lIns="0" tIns="0" rIns="0" bIns="0" anchor="t" anchorCtr="0">
+              <a:bodyPr wrap="square" lIns="0" tIns="0" rIns="0" bIns="0" anchor="t" anchorCtr="0">
                 <a:spAutoFit/>
               </a:bodyPr>
               <a:lstStyle/>
@@ -7202,7 +7238,7 @@
             <p:spPr>
               <a:xfrm>
                 <a:off x="1325499" y="5114925"/>
-                <a:ext cx="1925874" cy="308991"/>
+                <a:ext cx="2597842" cy="308991"/>
               </a:xfrm>
               <a:prstGeom prst="rect">
                 <a:avLst/>
@@ -7213,7 +7249,7 @@
               </a:ln>
             </p:spPr>
             <p:txBody>
-              <a:bodyPr wrap="none" lIns="0" tIns="0" rIns="0" bIns="0" anchor="t" anchorCtr="0">
+              <a:bodyPr wrap="square" lIns="0" tIns="0" rIns="0" bIns="0" anchor="t" anchorCtr="0">
                 <a:spAutoFit/>
               </a:bodyPr>
               <a:lstStyle/>
@@ -7282,7 +7318,7 @@
           <p:spPr>
             <a:xfrm>
               <a:off x="6471285" y="2279650"/>
-              <a:ext cx="2193651" cy="220028"/>
+              <a:ext cx="2932563" cy="220028"/>
             </a:xfrm>
             <a:prstGeom prst="rect">
               <a:avLst/>
@@ -7293,7 +7329,7 @@
             </a:ln>
           </p:spPr>
           <p:txBody>
-            <a:bodyPr wrap="none" lIns="0" tIns="0" rIns="0" bIns="0" anchor="t" anchorCtr="0">
+            <a:bodyPr wrap="square" lIns="0" tIns="0" rIns="0" bIns="0" anchor="t" anchorCtr="0">
               <a:spAutoFit/>
             </a:bodyPr>
             <a:lstStyle/>
@@ -7358,7 +7394,7 @@
             <p:spPr>
               <a:xfrm>
                 <a:off x="6849999" y="2828925"/>
-                <a:ext cx="2174864" cy="308991"/>
+                <a:ext cx="2909080" cy="308991"/>
               </a:xfrm>
               <a:prstGeom prst="rect">
                 <a:avLst/>
@@ -7369,7 +7405,7 @@
               </a:ln>
             </p:spPr>
             <p:txBody>
-              <a:bodyPr wrap="none" lIns="0" tIns="0" rIns="0" bIns="0" anchor="t" anchorCtr="0">
+              <a:bodyPr wrap="square" lIns="0" tIns="0" rIns="0" bIns="0" anchor="t" anchorCtr="0">
                 <a:spAutoFit/>
               </a:bodyPr>
               <a:lstStyle/>
@@ -7443,7 +7479,7 @@
             <p:spPr>
               <a:xfrm>
                 <a:off x="6849999" y="3590925"/>
-                <a:ext cx="2316588" cy="308991"/>
+                <a:ext cx="3086235" cy="308991"/>
               </a:xfrm>
               <a:prstGeom prst="rect">
                 <a:avLst/>
@@ -7454,7 +7490,7 @@
               </a:ln>
             </p:spPr>
             <p:txBody>
-              <a:bodyPr wrap="none" lIns="0" tIns="0" rIns="0" bIns="0" anchor="t" anchorCtr="0">
+              <a:bodyPr wrap="square" lIns="0" tIns="0" rIns="0" bIns="0" anchor="t" anchorCtr="0">
                 <a:spAutoFit/>
               </a:bodyPr>
               <a:lstStyle/>
@@ -7528,7 +7564,7 @@
             <p:spPr>
               <a:xfrm>
                 <a:off x="6849999" y="4352925"/>
-                <a:ext cx="1842858" cy="308991"/>
+                <a:ext cx="2494072" cy="308991"/>
               </a:xfrm>
               <a:prstGeom prst="rect">
                 <a:avLst/>
@@ -7539,7 +7575,7 @@
               </a:ln>
             </p:spPr>
             <p:txBody>
-              <a:bodyPr wrap="none" lIns="0" tIns="0" rIns="0" bIns="0" anchor="t" anchorCtr="0">
+              <a:bodyPr wrap="square" lIns="0" tIns="0" rIns="0" bIns="0" anchor="t" anchorCtr="0">
                 <a:spAutoFit/>
               </a:bodyPr>
               <a:lstStyle/>
@@ -7613,7 +7649,7 @@
             <p:spPr>
               <a:xfrm>
                 <a:off x="6849999" y="5114925"/>
-                <a:ext cx="2528562" cy="308991"/>
+                <a:ext cx="3351202" cy="308991"/>
               </a:xfrm>
               <a:prstGeom prst="rect">
                 <a:avLst/>
@@ -7624,7 +7660,7 @@
               </a:ln>
             </p:spPr>
             <p:txBody>
-              <a:bodyPr wrap="none" lIns="0" tIns="0" rIns="0" bIns="0" anchor="t" anchorCtr="0">
+              <a:bodyPr wrap="square" lIns="0" tIns="0" rIns="0" bIns="0" anchor="t" anchorCtr="0">
                 <a:spAutoFit/>
               </a:bodyPr>
               <a:lstStyle/>
@@ -7653,8 +7689,8 @@
           </p:nvSpPr>
           <p:spPr>
             <a:xfrm>
-              <a:off x="6470904" y="5695950"/>
-              <a:ext cx="4773602" cy="234696"/>
+              <a:off x="6470523" y="5695950"/>
+              <a:ext cx="6555238" cy="250317"/>
             </a:xfrm>
             <a:prstGeom prst="rect">
               <a:avLst/>
@@ -7665,14 +7701,14 @@
             </a:ln>
           </p:spPr>
           <p:txBody>
-            <a:bodyPr wrap="none" lIns="0" tIns="0" rIns="0" bIns="0" anchor="t" anchorCtr="0">
+            <a:bodyPr wrap="square" lIns="0" tIns="0" rIns="0" bIns="0" anchor="t" anchorCtr="0">
               <a:spAutoFit/>
             </a:bodyPr>
             <a:lstStyle/>
             <a:p>
               <a:pPr algn="l"/>
               <a:r>
-                <a:rPr lang="en" sz="1200" dirty="0">
+                <a:rPr lang="en" sz="1280" dirty="0">
                   <a:solidFill>
                     <a:srgbClr val="C8CFC9"/>
                   </a:solidFill>
@@ -7709,7 +7745,7 @@
           <p:spPr>
             <a:xfrm>
               <a:off x="603123" y="6419850"/>
-              <a:ext cx="547229" cy="250317"/>
+              <a:ext cx="839435" cy="250317"/>
             </a:xfrm>
             <a:prstGeom prst="rect">
               <a:avLst/>
@@ -7720,7 +7756,7 @@
             </a:ln>
           </p:spPr>
           <p:txBody>
-            <a:bodyPr wrap="none" lIns="0" tIns="0" rIns="0" bIns="0" anchor="t" anchorCtr="0">
+            <a:bodyPr wrap="square" lIns="0" tIns="0" rIns="0" bIns="0" anchor="t" anchorCtr="0">
               <a:spAutoFit/>
             </a:bodyPr>
             <a:lstStyle/>
@@ -7749,7 +7785,7 @@
           <p:spPr>
             <a:xfrm>
               <a:off x="1195197" y="6435725"/>
-              <a:ext cx="2013363" cy="191643"/>
+              <a:ext cx="2707203" cy="191643"/>
             </a:xfrm>
             <a:prstGeom prst="rect">
               <a:avLst/>
@@ -7760,7 +7796,7 @@
             </a:ln>
           </p:spPr>
           <p:txBody>
-            <a:bodyPr wrap="none" lIns="0" tIns="0" rIns="0" bIns="0" anchor="t" anchorCtr="0">
+            <a:bodyPr wrap="square" lIns="0" tIns="0" rIns="0" bIns="0" anchor="t" anchorCtr="0">
               <a:spAutoFit/>
             </a:bodyPr>
             <a:lstStyle/>
@@ -7782,22 +7818,34 @@
         </p:sp>
         <p:sp>
           <p:nvSpPr>
-            <p:cNvPr id="39" name="Rectangle 39"/>
+            <p:cNvPr id="39" name="Line 39"/>
             <p:cNvSpPr/>
             <p:nvPr/>
           </p:nvSpPr>
           <p:spPr>
             <a:xfrm>
-              <a:off x="11220450" y="6419850"/>
-              <a:ext cx="104775" cy="171450"/>
-            </a:xfrm>
-            <a:prstGeom prst="roundRect">
-              <a:avLst>
-                <a:gd name="adj" fmla="val 18182"/>
-              </a:avLst>
-            </a:prstGeom>
-            <a:noFill/>
-            <a:ln w="14288">
+              <a:off x="11068050" y="6515100"/>
+              <a:ext cx="190500" cy="9525"/>
+            </a:xfrm>
+            <a:custGeom>
+              <a:avLst/>
+              <a:gdLst/>
+              <a:ahLst/>
+              <a:cxnLst/>
+              <a:rect l="l" t="t" r="r" b="b"/>
+              <a:pathLst>
+                <a:path w="190500" h="9525">
+                  <a:moveTo>
+                    <a:pt x="0" y="0"/>
+                  </a:moveTo>
+                  <a:lnTo>
+                    <a:pt x="190500" y="0"/>
+                  </a:lnTo>
+                </a:path>
+              </a:pathLst>
+            </a:custGeom>
+            <a:noFill/>
+            <a:ln w="19050">
               <a:solidFill>
                 <a:srgbClr val="A8743A"/>
               </a:solidFill>
@@ -7812,8 +7860,8 @@
           </p:nvSpPr>
           <p:spPr>
             <a:xfrm>
-              <a:off x="11363705" y="6419850"/>
-              <a:ext cx="225172" cy="250317"/>
+              <a:off x="11154601" y="6419850"/>
+              <a:ext cx="434276" cy="250317"/>
             </a:xfrm>
             <a:prstGeom prst="rect">
               <a:avLst/>
@@ -7824,7 +7872,7 @@
             </a:ln>
           </p:spPr>
           <p:txBody>
-            <a:bodyPr wrap="none" lIns="0" tIns="0" rIns="0" bIns="0" anchor="t" anchorCtr="0">
+            <a:bodyPr wrap="square" lIns="0" tIns="0" rIns="0" bIns="0" anchor="t" anchorCtr="0">
               <a:spAutoFit/>
             </a:bodyPr>
             <a:lstStyle/>
@@ -7890,9 +7938,9 @@
         <p:grpSpPr>
           <a:xfrm>
             <a:off x="594360" y="565150"/>
-            <a:ext cx="9360869" cy="1118870"/>
+            <a:ext cx="8488172" cy="1118870"/>
             <a:chOff x="594360" y="565150"/>
-            <a:chExt cx="9360869" cy="1118870"/>
+            <a:chExt cx="8488172" cy="1118870"/>
           </a:xfrm>
         </p:grpSpPr>
         <p:sp>
@@ -7904,7 +7952,7 @@
           <p:spPr>
             <a:xfrm>
               <a:off x="603885" y="565150"/>
-              <a:ext cx="2197495" cy="220028"/>
+              <a:ext cx="2937368" cy="220028"/>
             </a:xfrm>
             <a:prstGeom prst="rect">
               <a:avLst/>
@@ -7915,7 +7963,7 @@
             </a:ln>
           </p:spPr>
           <p:txBody>
-            <a:bodyPr wrap="none" lIns="0" tIns="0" rIns="0" bIns="0" anchor="t" anchorCtr="0">
+            <a:bodyPr wrap="square" lIns="0" tIns="0" rIns="0" bIns="0" anchor="t" anchorCtr="0">
               <a:spAutoFit/>
             </a:bodyPr>
             <a:lstStyle/>
@@ -7944,7 +7992,7 @@
           <p:spPr>
             <a:xfrm>
               <a:off x="594360" y="850900"/>
-              <a:ext cx="9360869" cy="586740"/>
+              <a:ext cx="10800715" cy="586740"/>
             </a:xfrm>
             <a:prstGeom prst="rect">
               <a:avLst/>
@@ -7955,7 +8003,7 @@
             </a:ln>
           </p:spPr>
           <p:txBody>
-            <a:bodyPr wrap="none" lIns="0" tIns="0" rIns="0" bIns="0" anchor="t" anchorCtr="0">
+            <a:bodyPr wrap="square" lIns="0" tIns="0" rIns="0" bIns="0" anchor="t" anchorCtr="0">
               <a:spAutoFit/>
             </a:bodyPr>
             <a:lstStyle/>
@@ -7984,7 +8032,7 @@
           <p:spPr>
             <a:xfrm>
               <a:off x="601980" y="1390650"/>
-              <a:ext cx="4635546" cy="293370"/>
+              <a:ext cx="5984932" cy="293370"/>
             </a:xfrm>
             <a:prstGeom prst="rect">
               <a:avLst/>
@@ -7995,7 +8043,7 @@
             </a:ln>
           </p:spPr>
           <p:txBody>
-            <a:bodyPr wrap="none" lIns="0" tIns="0" rIns="0" bIns="0" anchor="t" anchorCtr="0">
+            <a:bodyPr wrap="square" lIns="0" tIns="0" rIns="0" bIns="0" anchor="t" anchorCtr="0">
               <a:spAutoFit/>
             </a:bodyPr>
             <a:lstStyle/>
@@ -8061,7 +8109,7 @@
           <p:spPr>
             <a:xfrm>
               <a:off x="864870" y="2349500"/>
-              <a:ext cx="356822" cy="440055"/>
+              <a:ext cx="619125" cy="440055"/>
             </a:xfrm>
             <a:prstGeom prst="rect">
               <a:avLst/>
@@ -8072,7 +8120,7 @@
             </a:ln>
           </p:spPr>
           <p:txBody>
-            <a:bodyPr wrap="none" lIns="0" tIns="0" rIns="0" bIns="0" anchor="t" anchorCtr="0">
+            <a:bodyPr wrap="square" lIns="0" tIns="0" rIns="0" bIns="0" anchor="t" anchorCtr="0">
               <a:spAutoFit/>
             </a:bodyPr>
             <a:lstStyle/>
@@ -8101,7 +8149,7 @@
           <p:spPr>
             <a:xfrm>
               <a:off x="600456" y="3251200"/>
-              <a:ext cx="1706753" cy="352044"/>
+              <a:ext cx="2137731" cy="352044"/>
             </a:xfrm>
             <a:prstGeom prst="rect">
               <a:avLst/>
@@ -8112,7 +8160,7 @@
             </a:ln>
           </p:spPr>
           <p:txBody>
-            <a:bodyPr wrap="none" lIns="0" tIns="0" rIns="0" bIns="0" anchor="t" anchorCtr="0">
+            <a:bodyPr wrap="square" lIns="0" tIns="0" rIns="0" bIns="0" anchor="t" anchorCtr="0">
               <a:spAutoFit/>
             </a:bodyPr>
             <a:lstStyle/>
@@ -8141,7 +8189,7 @@
           <p:spPr>
             <a:xfrm>
               <a:off x="602742" y="3638550"/>
-              <a:ext cx="1967560" cy="778383"/>
+              <a:ext cx="2649950" cy="778383"/>
             </a:xfrm>
             <a:prstGeom prst="rect">
               <a:avLst/>
@@ -8152,7 +8200,7 @@
             </a:ln>
           </p:spPr>
           <p:txBody>
-            <a:bodyPr wrap="none" lIns="0" tIns="0" rIns="0" bIns="0" anchor="t" anchorCtr="0">
+            <a:bodyPr wrap="square" lIns="0" tIns="0" rIns="0" bIns="0" anchor="t" anchorCtr="0">
               <a:spAutoFit/>
             </a:bodyPr>
             <a:lstStyle/>
@@ -8264,7 +8312,7 @@
           <p:spPr>
             <a:xfrm>
               <a:off x="3893820" y="2349500"/>
-              <a:ext cx="398075" cy="440055"/>
+              <a:ext cx="619125" cy="440055"/>
             </a:xfrm>
             <a:prstGeom prst="rect">
               <a:avLst/>
@@ -8275,7 +8323,7 @@
             </a:ln>
           </p:spPr>
           <p:txBody>
-            <a:bodyPr wrap="none" lIns="0" tIns="0" rIns="0" bIns="0" anchor="t" anchorCtr="0">
+            <a:bodyPr wrap="square" lIns="0" tIns="0" rIns="0" bIns="0" anchor="t" anchorCtr="0">
               <a:spAutoFit/>
             </a:bodyPr>
             <a:lstStyle/>
@@ -8304,7 +8352,7 @@
           <p:spPr>
             <a:xfrm>
               <a:off x="3591306" y="3251200"/>
-              <a:ext cx="2418690" cy="352044"/>
+              <a:ext cx="2920616" cy="352044"/>
             </a:xfrm>
             <a:prstGeom prst="rect">
               <a:avLst/>
@@ -8315,7 +8363,7 @@
             </a:ln>
           </p:spPr>
           <p:txBody>
-            <a:bodyPr wrap="none" lIns="0" tIns="0" rIns="0" bIns="0" anchor="t" anchorCtr="0">
+            <a:bodyPr wrap="square" lIns="0" tIns="0" rIns="0" bIns="0" anchor="t" anchorCtr="0">
               <a:spAutoFit/>
             </a:bodyPr>
             <a:lstStyle/>
@@ -8344,7 +8392,7 @@
           <p:spPr>
             <a:xfrm>
               <a:off x="3593592" y="3638550"/>
-              <a:ext cx="2176935" cy="778383"/>
+              <a:ext cx="2911668" cy="778383"/>
             </a:xfrm>
             <a:prstGeom prst="rect">
               <a:avLst/>
@@ -8355,7 +8403,7 @@
             </a:ln>
           </p:spPr>
           <p:txBody>
-            <a:bodyPr wrap="none" lIns="0" tIns="0" rIns="0" bIns="0" anchor="t" anchorCtr="0">
+            <a:bodyPr wrap="square" lIns="0" tIns="0" rIns="0" bIns="0" anchor="t" anchorCtr="0">
               <a:spAutoFit/>
             </a:bodyPr>
             <a:lstStyle/>
@@ -8467,7 +8515,7 @@
           <p:spPr>
             <a:xfrm>
               <a:off x="6598920" y="2349500"/>
-              <a:ext cx="395899" cy="440055"/>
+              <a:ext cx="619125" cy="440055"/>
             </a:xfrm>
             <a:prstGeom prst="rect">
               <a:avLst/>
@@ -8478,7 +8526,7 @@
             </a:ln>
           </p:spPr>
           <p:txBody>
-            <a:bodyPr wrap="none" lIns="0" tIns="0" rIns="0" bIns="0" anchor="t" anchorCtr="0">
+            <a:bodyPr wrap="square" lIns="0" tIns="0" rIns="0" bIns="0" anchor="t" anchorCtr="0">
               <a:spAutoFit/>
             </a:bodyPr>
             <a:lstStyle/>
@@ -8507,7 +8555,7 @@
           <p:spPr>
             <a:xfrm>
               <a:off x="6296406" y="3251200"/>
-              <a:ext cx="2197311" cy="352044"/>
+              <a:ext cx="2669906" cy="352044"/>
             </a:xfrm>
             <a:prstGeom prst="rect">
               <a:avLst/>
@@ -8518,7 +8566,7 @@
             </a:ln>
           </p:spPr>
           <p:txBody>
-            <a:bodyPr wrap="none" lIns="0" tIns="0" rIns="0" bIns="0" anchor="t" anchorCtr="0">
+            <a:bodyPr wrap="square" lIns="0" tIns="0" rIns="0" bIns="0" anchor="t" anchorCtr="0">
               <a:spAutoFit/>
             </a:bodyPr>
             <a:lstStyle/>
@@ -8547,7 +8595,7 @@
           <p:spPr>
             <a:xfrm>
               <a:off x="6298692" y="3638550"/>
-              <a:ext cx="2081917" cy="778383"/>
+              <a:ext cx="2792896" cy="778383"/>
             </a:xfrm>
             <a:prstGeom prst="rect">
               <a:avLst/>
@@ -8558,7 +8606,7 @@
             </a:ln>
           </p:spPr>
           <p:txBody>
-            <a:bodyPr wrap="none" lIns="0" tIns="0" rIns="0" bIns="0" anchor="t" anchorCtr="0">
+            <a:bodyPr wrap="square" lIns="0" tIns="0" rIns="0" bIns="0" anchor="t" anchorCtr="0">
               <a:spAutoFit/>
             </a:bodyPr>
             <a:lstStyle/>
@@ -8670,7 +8718,7 @@
           <p:spPr>
             <a:xfrm>
               <a:off x="9304020" y="2349500"/>
-              <a:ext cx="400091" cy="440055"/>
+              <a:ext cx="619125" cy="440055"/>
             </a:xfrm>
             <a:prstGeom prst="rect">
               <a:avLst/>
@@ -8681,7 +8729,7 @@
             </a:ln>
           </p:spPr>
           <p:txBody>
-            <a:bodyPr wrap="none" lIns="0" tIns="0" rIns="0" bIns="0" anchor="t" anchorCtr="0">
+            <a:bodyPr wrap="square" lIns="0" tIns="0" rIns="0" bIns="0" anchor="t" anchorCtr="0">
               <a:spAutoFit/>
             </a:bodyPr>
             <a:lstStyle/>
@@ -8710,7 +8758,7 @@
           <p:spPr>
             <a:xfrm>
               <a:off x="9001506" y="3251200"/>
-              <a:ext cx="2028623" cy="352044"/>
+              <a:ext cx="2556733" cy="352044"/>
             </a:xfrm>
             <a:prstGeom prst="rect">
               <a:avLst/>
@@ -8721,7 +8769,7 @@
             </a:ln>
           </p:spPr>
           <p:txBody>
-            <a:bodyPr wrap="none" lIns="0" tIns="0" rIns="0" bIns="0" anchor="t" anchorCtr="0">
+            <a:bodyPr wrap="square" lIns="0" tIns="0" rIns="0" bIns="0" anchor="t" anchorCtr="0">
               <a:spAutoFit/>
             </a:bodyPr>
             <a:lstStyle/>
@@ -8750,7 +8798,7 @@
           <p:spPr>
             <a:xfrm>
               <a:off x="9003792" y="3638550"/>
-              <a:ext cx="1957445" cy="778383"/>
+              <a:ext cx="2637306" cy="778383"/>
             </a:xfrm>
             <a:prstGeom prst="rect">
               <a:avLst/>
@@ -8761,7 +8809,7 @@
             </a:ln>
           </p:spPr>
           <p:txBody>
-            <a:bodyPr wrap="none" lIns="0" tIns="0" rIns="0" bIns="0" anchor="t" anchorCtr="0">
+            <a:bodyPr wrap="square" lIns="0" tIns="0" rIns="0" bIns="0" anchor="t" anchorCtr="0">
               <a:spAutoFit/>
             </a:bodyPr>
             <a:lstStyle/>
@@ -8936,7 +8984,7 @@
           <p:spPr>
             <a:xfrm>
               <a:off x="1382268" y="5607050"/>
-              <a:ext cx="8229955" cy="322707"/>
+              <a:ext cx="10477943" cy="322707"/>
             </a:xfrm>
             <a:prstGeom prst="rect">
               <a:avLst/>
@@ -8947,7 +8995,7 @@
             </a:ln>
           </p:spPr>
           <p:txBody>
-            <a:bodyPr wrap="none" lIns="0" tIns="0" rIns="0" bIns="0" anchor="t" anchorCtr="0">
+            <a:bodyPr wrap="square" lIns="0" tIns="0" rIns="0" bIns="0" anchor="t" anchorCtr="0">
               <a:spAutoFit/>
             </a:bodyPr>
             <a:lstStyle/>
@@ -9002,7 +9050,7 @@
           <p:spPr>
             <a:xfrm>
               <a:off x="603123" y="6419850"/>
-              <a:ext cx="547229" cy="250317"/>
+              <a:ext cx="839435" cy="250317"/>
             </a:xfrm>
             <a:prstGeom prst="rect">
               <a:avLst/>
@@ -9013,7 +9061,7 @@
             </a:ln>
           </p:spPr>
           <p:txBody>
-            <a:bodyPr wrap="none" lIns="0" tIns="0" rIns="0" bIns="0" anchor="t" anchorCtr="0">
+            <a:bodyPr wrap="square" lIns="0" tIns="0" rIns="0" bIns="0" anchor="t" anchorCtr="0">
               <a:spAutoFit/>
             </a:bodyPr>
             <a:lstStyle/>
@@ -9042,7 +9090,7 @@
           <p:spPr>
             <a:xfrm>
               <a:off x="1195197" y="6435725"/>
-              <a:ext cx="2013363" cy="191643"/>
+              <a:ext cx="2707203" cy="191643"/>
             </a:xfrm>
             <a:prstGeom prst="rect">
               <a:avLst/>
@@ -9053,7 +9101,7 @@
             </a:ln>
           </p:spPr>
           <p:txBody>
-            <a:bodyPr wrap="none" lIns="0" tIns="0" rIns="0" bIns="0" anchor="t" anchorCtr="0">
+            <a:bodyPr wrap="square" lIns="0" tIns="0" rIns="0" bIns="0" anchor="t" anchorCtr="0">
               <a:spAutoFit/>
             </a:bodyPr>
             <a:lstStyle/>
@@ -9075,22 +9123,34 @@
         </p:sp>
         <p:sp>
           <p:nvSpPr>
-            <p:cNvPr id="33" name="Rectangle 33"/>
+            <p:cNvPr id="33" name="Line 33"/>
             <p:cNvSpPr/>
             <p:nvPr/>
           </p:nvSpPr>
           <p:spPr>
             <a:xfrm>
-              <a:off x="11220450" y="6419850"/>
-              <a:ext cx="104775" cy="171450"/>
-            </a:xfrm>
-            <a:prstGeom prst="roundRect">
-              <a:avLst>
-                <a:gd name="adj" fmla="val 18182"/>
-              </a:avLst>
-            </a:prstGeom>
-            <a:noFill/>
-            <a:ln w="14288">
+              <a:off x="11068050" y="6515100"/>
+              <a:ext cx="190500" cy="9525"/>
+            </a:xfrm>
+            <a:custGeom>
+              <a:avLst/>
+              <a:gdLst/>
+              <a:ahLst/>
+              <a:cxnLst/>
+              <a:rect l="l" t="t" r="r" b="b"/>
+              <a:pathLst>
+                <a:path w="190500" h="9525">
+                  <a:moveTo>
+                    <a:pt x="0" y="0"/>
+                  </a:moveTo>
+                  <a:lnTo>
+                    <a:pt x="190500" y="0"/>
+                  </a:lnTo>
+                </a:path>
+              </a:pathLst>
+            </a:custGeom>
+            <a:noFill/>
+            <a:ln w="19050">
               <a:solidFill>
                 <a:srgbClr val="A8743A"/>
               </a:solidFill>
@@ -9105,8 +9165,8 @@
           </p:nvSpPr>
           <p:spPr>
             <a:xfrm>
-              <a:off x="11361320" y="6419850"/>
-              <a:ext cx="227557" cy="250317"/>
+              <a:off x="11154601" y="6419850"/>
+              <a:ext cx="434276" cy="250317"/>
             </a:xfrm>
             <a:prstGeom prst="rect">
               <a:avLst/>
@@ -9117,7 +9177,7 @@
             </a:ln>
           </p:spPr>
           <p:txBody>
-            <a:bodyPr wrap="none" lIns="0" tIns="0" rIns="0" bIns="0" anchor="t" anchorCtr="0">
+            <a:bodyPr wrap="square" lIns="0" tIns="0" rIns="0" bIns="0" anchor="t" anchorCtr="0">
               <a:spAutoFit/>
             </a:bodyPr>
             <a:lstStyle/>
@@ -9183,9 +9243,9 @@
         <p:grpSpPr>
           <a:xfrm>
             <a:off x="594360" y="565150"/>
-            <a:ext cx="8929866" cy="1118870"/>
+            <a:ext cx="8119560" cy="1118870"/>
             <a:chOff x="594360" y="565150"/>
-            <a:chExt cx="8929866" cy="1118870"/>
+            <a:chExt cx="8119560" cy="1118870"/>
           </a:xfrm>
         </p:grpSpPr>
         <p:sp>
@@ -9197,7 +9257,7 @@
           <p:spPr>
             <a:xfrm>
               <a:off x="603885" y="565150"/>
-              <a:ext cx="3177492" cy="220028"/>
+              <a:ext cx="4162365" cy="220028"/>
             </a:xfrm>
             <a:prstGeom prst="rect">
               <a:avLst/>
@@ -9208,7 +9268,7 @@
             </a:ln>
           </p:spPr>
           <p:txBody>
-            <a:bodyPr wrap="none" lIns="0" tIns="0" rIns="0" bIns="0" anchor="t" anchorCtr="0">
+            <a:bodyPr wrap="square" lIns="0" tIns="0" rIns="0" bIns="0" anchor="t" anchorCtr="0">
               <a:spAutoFit/>
             </a:bodyPr>
             <a:lstStyle/>
@@ -9237,7 +9297,7 @@
           <p:spPr>
             <a:xfrm>
               <a:off x="594360" y="850900"/>
-              <a:ext cx="8929866" cy="586740"/>
+              <a:ext cx="10339950" cy="586740"/>
             </a:xfrm>
             <a:prstGeom prst="rect">
               <a:avLst/>
@@ -9248,7 +9308,7 @@
             </a:ln>
           </p:spPr>
           <p:txBody>
-            <a:bodyPr wrap="none" lIns="0" tIns="0" rIns="0" bIns="0" anchor="t" anchorCtr="0">
+            <a:bodyPr wrap="square" lIns="0" tIns="0" rIns="0" bIns="0" anchor="t" anchorCtr="0">
               <a:spAutoFit/>
             </a:bodyPr>
             <a:lstStyle/>
@@ -9277,7 +9337,7 @@
           <p:spPr>
             <a:xfrm>
               <a:off x="601980" y="1390650"/>
-              <a:ext cx="5695997" cy="293370"/>
+              <a:ext cx="7310496" cy="293370"/>
             </a:xfrm>
             <a:prstGeom prst="rect">
               <a:avLst/>
@@ -9288,7 +9348,7 @@
             </a:ln>
           </p:spPr>
           <p:txBody>
-            <a:bodyPr wrap="none" lIns="0" tIns="0" rIns="0" bIns="0" anchor="t" anchorCtr="0">
+            <a:bodyPr wrap="square" lIns="0" tIns="0" rIns="0" bIns="0" anchor="t" anchorCtr="0">
               <a:spAutoFit/>
             </a:bodyPr>
             <a:lstStyle/>
@@ -9360,7 +9420,7 @@
           <p:spPr>
             <a:xfrm>
               <a:off x="947166" y="2216150"/>
-              <a:ext cx="2746285" cy="205359"/>
+              <a:ext cx="3623356" cy="205359"/>
             </a:xfrm>
             <a:prstGeom prst="rect">
               <a:avLst/>
@@ -9371,7 +9431,7 @@
             </a:ln>
           </p:spPr>
           <p:txBody>
-            <a:bodyPr wrap="none" lIns="0" tIns="0" rIns="0" bIns="0" anchor="t" anchorCtr="0">
+            <a:bodyPr wrap="square" lIns="0" tIns="0" rIns="0" bIns="0" anchor="t" anchorCtr="0">
               <a:spAutoFit/>
             </a:bodyPr>
             <a:lstStyle/>
@@ -9436,7 +9496,7 @@
           <p:spPr>
             <a:xfrm>
               <a:off x="942594" y="2622550"/>
-              <a:ext cx="5133983" cy="1905381"/>
+              <a:ext cx="5650067" cy="1905381"/>
             </a:xfrm>
             <a:prstGeom prst="rect">
               <a:avLst/>
@@ -9447,7 +9507,7 @@
             </a:ln>
           </p:spPr>
           <p:txBody>
-            <a:bodyPr wrap="none" lIns="0" tIns="0" rIns="0" bIns="0" anchor="t" anchorCtr="0">
+            <a:bodyPr wrap="square" lIns="0" tIns="0" rIns="0" bIns="0" anchor="t" anchorCtr="0">
               <a:spAutoFit/>
             </a:bodyPr>
             <a:lstStyle/>
@@ -9597,7 +9657,7 @@
           <p:spPr>
             <a:xfrm>
               <a:off x="1861185" y="5403850"/>
-              <a:ext cx="3563187" cy="220028"/>
+              <a:ext cx="4644483" cy="220028"/>
             </a:xfrm>
             <a:prstGeom prst="rect">
               <a:avLst/>
@@ -9608,7 +9668,7 @@
             </a:ln>
           </p:spPr>
           <p:txBody>
-            <a:bodyPr wrap="none" lIns="0" tIns="0" rIns="0" bIns="0" anchor="t" anchorCtr="0">
+            <a:bodyPr wrap="square" lIns="0" tIns="0" rIns="0" bIns="0" anchor="t" anchorCtr="0">
               <a:spAutoFit/>
             </a:bodyPr>
             <a:lstStyle/>
@@ -9652,7 +9712,7 @@
           <p:spPr>
             <a:xfrm>
               <a:off x="7804785" y="2012950"/>
-              <a:ext cx="1458498" cy="220028"/>
+              <a:ext cx="2013622" cy="220028"/>
             </a:xfrm>
             <a:prstGeom prst="rect">
               <a:avLst/>
@@ -9663,7 +9723,7 @@
             </a:ln>
           </p:spPr>
           <p:txBody>
-            <a:bodyPr wrap="none" lIns="0" tIns="0" rIns="0" bIns="0" anchor="t" anchorCtr="0">
+            <a:bodyPr wrap="square" lIns="0" tIns="0" rIns="0" bIns="0" anchor="t" anchorCtr="0">
               <a:spAutoFit/>
             </a:bodyPr>
             <a:lstStyle/>
@@ -9727,8 +9787,8 @@
             </p:nvSpPr>
             <p:spPr>
               <a:xfrm>
-                <a:off x="7931315" y="2479675"/>
-                <a:ext cx="101269" cy="278702"/>
+                <a:off x="7814533" y="2479675"/>
+                <a:ext cx="334835" cy="278702"/>
               </a:xfrm>
               <a:prstGeom prst="rect">
                 <a:avLst/>
@@ -9739,7 +9799,7 @@
               </a:ln>
             </p:spPr>
             <p:txBody>
-              <a:bodyPr wrap="none" lIns="0" tIns="0" rIns="0" bIns="0" anchor="t" anchorCtr="0">
+              <a:bodyPr wrap="square" lIns="0" tIns="0" rIns="0" bIns="0" anchor="t" anchorCtr="0">
                 <a:spAutoFit/>
               </a:bodyPr>
               <a:lstStyle/>
@@ -9768,7 +9828,7 @@
             <p:spPr>
               <a:xfrm>
                 <a:off x="8298561" y="2393950"/>
-                <a:ext cx="1943012" cy="278702"/>
+                <a:ext cx="2619265" cy="278702"/>
               </a:xfrm>
               <a:prstGeom prst="rect">
                 <a:avLst/>
@@ -9779,7 +9839,7 @@
               </a:ln>
             </p:spPr>
             <p:txBody>
-              <a:bodyPr wrap="none" lIns="0" tIns="0" rIns="0" bIns="0" anchor="t" anchorCtr="0">
+              <a:bodyPr wrap="square" lIns="0" tIns="0" rIns="0" bIns="0" anchor="t" anchorCtr="0">
                 <a:spAutoFit/>
               </a:bodyPr>
               <a:lstStyle/>
@@ -9808,7 +9868,7 @@
             <p:spPr>
               <a:xfrm>
                 <a:off x="8299323" y="2679700"/>
-                <a:ext cx="1892440" cy="488442"/>
+                <a:ext cx="2556050" cy="488442"/>
               </a:xfrm>
               <a:prstGeom prst="rect">
                 <a:avLst/>
@@ -9819,7 +9879,7 @@
               </a:ln>
             </p:spPr>
             <p:txBody>
-              <a:bodyPr wrap="none" lIns="0" tIns="0" rIns="0" bIns="0" anchor="t" anchorCtr="0">
+              <a:bodyPr wrap="square" lIns="0" tIns="0" rIns="0" bIns="0" anchor="t" anchorCtr="0">
                 <a:spAutoFit/>
               </a:bodyPr>
               <a:lstStyle/>
@@ -9945,8 +10005,8 @@
             </p:nvSpPr>
             <p:spPr>
               <a:xfrm>
-                <a:off x="7918298" y="3717925"/>
-                <a:ext cx="127304" cy="278702"/>
+                <a:off x="7814533" y="3717925"/>
+                <a:ext cx="334835" cy="278702"/>
               </a:xfrm>
               <a:prstGeom prst="rect">
                 <a:avLst/>
@@ -9957,7 +10017,7 @@
               </a:ln>
             </p:spPr>
             <p:txBody>
-              <a:bodyPr wrap="none" lIns="0" tIns="0" rIns="0" bIns="0" anchor="t" anchorCtr="0">
+              <a:bodyPr wrap="square" lIns="0" tIns="0" rIns="0" bIns="0" anchor="t" anchorCtr="0">
                 <a:spAutoFit/>
               </a:bodyPr>
               <a:lstStyle/>
@@ -9986,7 +10046,7 @@
             <p:spPr>
               <a:xfrm>
                 <a:off x="8298561" y="3632200"/>
-                <a:ext cx="2134857" cy="278702"/>
+                <a:ext cx="2859071" cy="278702"/>
               </a:xfrm>
               <a:prstGeom prst="rect">
                 <a:avLst/>
@@ -9997,7 +10057,7 @@
               </a:ln>
             </p:spPr>
             <p:txBody>
-              <a:bodyPr wrap="none" lIns="0" tIns="0" rIns="0" bIns="0" anchor="t" anchorCtr="0">
+              <a:bodyPr wrap="square" lIns="0" tIns="0" rIns="0" bIns="0" anchor="t" anchorCtr="0">
                 <a:spAutoFit/>
               </a:bodyPr>
               <a:lstStyle/>
@@ -10026,7 +10086,7 @@
             <p:spPr>
               <a:xfrm>
                 <a:off x="8299323" y="3917950"/>
-                <a:ext cx="1747729" cy="488442"/>
+                <a:ext cx="2375161" cy="488442"/>
               </a:xfrm>
               <a:prstGeom prst="rect">
                 <a:avLst/>
@@ -10037,7 +10097,7 @@
               </a:ln>
             </p:spPr>
             <p:txBody>
-              <a:bodyPr wrap="none" lIns="0" tIns="0" rIns="0" bIns="0" anchor="t" anchorCtr="0">
+              <a:bodyPr wrap="square" lIns="0" tIns="0" rIns="0" bIns="0" anchor="t" anchorCtr="0">
                 <a:spAutoFit/>
               </a:bodyPr>
               <a:lstStyle/>
@@ -10163,8 +10223,8 @@
             </p:nvSpPr>
             <p:spPr>
               <a:xfrm>
-                <a:off x="7918984" y="4956175"/>
-                <a:ext cx="125931" cy="278702"/>
+                <a:off x="7814533" y="4956175"/>
+                <a:ext cx="334835" cy="278702"/>
               </a:xfrm>
               <a:prstGeom prst="rect">
                 <a:avLst/>
@@ -10175,7 +10235,7 @@
               </a:ln>
             </p:spPr>
             <p:txBody>
-              <a:bodyPr wrap="none" lIns="0" tIns="0" rIns="0" bIns="0" anchor="t" anchorCtr="0">
+              <a:bodyPr wrap="square" lIns="0" tIns="0" rIns="0" bIns="0" anchor="t" anchorCtr="0">
                 <a:spAutoFit/>
               </a:bodyPr>
               <a:lstStyle/>
@@ -10204,7 +10264,7 @@
             <p:spPr>
               <a:xfrm>
                 <a:off x="8298561" y="4870450"/>
-                <a:ext cx="2315889" cy="278702"/>
+                <a:ext cx="3085361" cy="278702"/>
               </a:xfrm>
               <a:prstGeom prst="rect">
                 <a:avLst/>
@@ -10215,7 +10275,7 @@
               </a:ln>
             </p:spPr>
             <p:txBody>
-              <a:bodyPr wrap="none" lIns="0" tIns="0" rIns="0" bIns="0" anchor="t" anchorCtr="0">
+              <a:bodyPr wrap="square" lIns="0" tIns="0" rIns="0" bIns="0" anchor="t" anchorCtr="0">
                 <a:spAutoFit/>
               </a:bodyPr>
               <a:lstStyle/>
@@ -10244,7 +10304,7 @@
             <p:spPr>
               <a:xfrm>
                 <a:off x="8299323" y="5156200"/>
-                <a:ext cx="1874006" cy="488442"/>
+                <a:ext cx="2533007" cy="488442"/>
               </a:xfrm>
               <a:prstGeom prst="rect">
                 <a:avLst/>
@@ -10255,7 +10315,7 @@
               </a:ln>
             </p:spPr>
             <p:txBody>
-              <a:bodyPr wrap="none" lIns="0" tIns="0" rIns="0" bIns="0" anchor="t" anchorCtr="0">
+              <a:bodyPr wrap="square" lIns="0" tIns="0" rIns="0" bIns="0" anchor="t" anchorCtr="0">
                 <a:spAutoFit/>
               </a:bodyPr>
               <a:lstStyle/>
@@ -10325,7 +10385,7 @@
           <p:spPr>
             <a:xfrm>
               <a:off x="603123" y="6419850"/>
-              <a:ext cx="547229" cy="250317"/>
+              <a:ext cx="839435" cy="250317"/>
             </a:xfrm>
             <a:prstGeom prst="rect">
               <a:avLst/>
@@ -10336,7 +10396,7 @@
             </a:ln>
           </p:spPr>
           <p:txBody>
-            <a:bodyPr wrap="none" lIns="0" tIns="0" rIns="0" bIns="0" anchor="t" anchorCtr="0">
+            <a:bodyPr wrap="square" lIns="0" tIns="0" rIns="0" bIns="0" anchor="t" anchorCtr="0">
               <a:spAutoFit/>
             </a:bodyPr>
             <a:lstStyle/>
@@ -10365,7 +10425,7 @@
           <p:spPr>
             <a:xfrm>
               <a:off x="1195197" y="6435725"/>
-              <a:ext cx="2013363" cy="191643"/>
+              <a:ext cx="2707203" cy="191643"/>
             </a:xfrm>
             <a:prstGeom prst="rect">
               <a:avLst/>
@@ -10376,7 +10436,7 @@
             </a:ln>
           </p:spPr>
           <p:txBody>
-            <a:bodyPr wrap="none" lIns="0" tIns="0" rIns="0" bIns="0" anchor="t" anchorCtr="0">
+            <a:bodyPr wrap="square" lIns="0" tIns="0" rIns="0" bIns="0" anchor="t" anchorCtr="0">
               <a:spAutoFit/>
             </a:bodyPr>
             <a:lstStyle/>
@@ -10398,22 +10458,34 @@
         </p:sp>
         <p:sp>
           <p:nvSpPr>
-            <p:cNvPr id="33" name="Rectangle 33"/>
+            <p:cNvPr id="33" name="Line 33"/>
             <p:cNvSpPr/>
             <p:nvPr/>
           </p:nvSpPr>
           <p:spPr>
             <a:xfrm>
-              <a:off x="11220450" y="6419850"/>
-              <a:ext cx="104775" cy="171450"/>
-            </a:xfrm>
-            <a:prstGeom prst="roundRect">
-              <a:avLst>
-                <a:gd name="adj" fmla="val 18182"/>
-              </a:avLst>
-            </a:prstGeom>
-            <a:noFill/>
-            <a:ln w="14288">
+              <a:off x="11068050" y="6515100"/>
+              <a:ext cx="190500" cy="9525"/>
+            </a:xfrm>
+            <a:custGeom>
+              <a:avLst/>
+              <a:gdLst/>
+              <a:ahLst/>
+              <a:cxnLst/>
+              <a:rect l="l" t="t" r="r" b="b"/>
+              <a:pathLst>
+                <a:path w="190500" h="9525">
+                  <a:moveTo>
+                    <a:pt x="0" y="0"/>
+                  </a:moveTo>
+                  <a:lnTo>
+                    <a:pt x="190500" y="0"/>
+                  </a:lnTo>
+                </a:path>
+              </a:pathLst>
+            </a:custGeom>
+            <a:noFill/>
+            <a:ln w="19050">
               <a:solidFill>
                 <a:srgbClr val="A8743A"/>
               </a:solidFill>
@@ -10428,8 +10500,8 @@
           </p:nvSpPr>
           <p:spPr>
             <a:xfrm>
-              <a:off x="11367984" y="6419850"/>
-              <a:ext cx="220893" cy="250317"/>
+              <a:off x="11154601" y="6419850"/>
+              <a:ext cx="434276" cy="250317"/>
             </a:xfrm>
             <a:prstGeom prst="rect">
               <a:avLst/>
@@ -10440,7 +10512,7 @@
             </a:ln>
           </p:spPr>
           <p:txBody>
-            <a:bodyPr wrap="none" lIns="0" tIns="0" rIns="0" bIns="0" anchor="t" anchorCtr="0">
+            <a:bodyPr wrap="square" lIns="0" tIns="0" rIns="0" bIns="0" anchor="t" anchorCtr="0">
               <a:spAutoFit/>
             </a:bodyPr>
             <a:lstStyle/>
@@ -10506,9 +10578,9 @@
         <p:grpSpPr>
           <a:xfrm>
             <a:off x="594360" y="565150"/>
-            <a:ext cx="8917214" cy="1118870"/>
+            <a:ext cx="8068788" cy="1118870"/>
             <a:chOff x="594360" y="565150"/>
-            <a:chExt cx="8917214" cy="1118870"/>
+            <a:chExt cx="8068788" cy="1118870"/>
           </a:xfrm>
         </p:grpSpPr>
         <p:sp>
@@ -10520,7 +10592,7 @@
           <p:spPr>
             <a:xfrm>
               <a:off x="603885" y="565150"/>
-              <a:ext cx="2296933" cy="220028"/>
+              <a:ext cx="3061666" cy="220028"/>
             </a:xfrm>
             <a:prstGeom prst="rect">
               <a:avLst/>
@@ -10531,7 +10603,7 @@
             </a:ln>
           </p:spPr>
           <p:txBody>
-            <a:bodyPr wrap="none" lIns="0" tIns="0" rIns="0" bIns="0" anchor="t" anchorCtr="0">
+            <a:bodyPr wrap="square" lIns="0" tIns="0" rIns="0" bIns="0" anchor="t" anchorCtr="0">
               <a:spAutoFit/>
             </a:bodyPr>
             <a:lstStyle/>
@@ -10560,7 +10632,7 @@
           <p:spPr>
             <a:xfrm>
               <a:off x="594360" y="850900"/>
-              <a:ext cx="8917214" cy="586740"/>
+              <a:ext cx="10276485" cy="586740"/>
             </a:xfrm>
             <a:prstGeom prst="rect">
               <a:avLst/>
@@ -10571,7 +10643,7 @@
             </a:ln>
           </p:spPr>
           <p:txBody>
-            <a:bodyPr wrap="none" lIns="0" tIns="0" rIns="0" bIns="0" anchor="t" anchorCtr="0">
+            <a:bodyPr wrap="square" lIns="0" tIns="0" rIns="0" bIns="0" anchor="t" anchorCtr="0">
               <a:spAutoFit/>
             </a:bodyPr>
             <a:lstStyle/>
@@ -10600,7 +10672,7 @@
           <p:spPr>
             <a:xfrm>
               <a:off x="601980" y="1390650"/>
-              <a:ext cx="6744691" cy="293370"/>
+              <a:ext cx="8621363" cy="293370"/>
             </a:xfrm>
             <a:prstGeom prst="rect">
               <a:avLst/>
@@ -10611,7 +10683,7 @@
             </a:ln>
           </p:spPr>
           <p:txBody>
-            <a:bodyPr wrap="none" lIns="0" tIns="0" rIns="0" bIns="0" anchor="t" anchorCtr="0">
+            <a:bodyPr wrap="square" lIns="0" tIns="0" rIns="0" bIns="0" anchor="t" anchorCtr="0">
               <a:spAutoFit/>
             </a:bodyPr>
             <a:lstStyle/>
@@ -10679,7 +10751,7 @@
           <p:spPr>
             <a:xfrm>
               <a:off x="971550" y="2152650"/>
-              <a:ext cx="2429258" cy="2733675"/>
+              <a:ext cx="2771775" cy="2733675"/>
             </a:xfrm>
             <a:prstGeom prst="rect">
               <a:avLst/>
@@ -10690,7 +10762,7 @@
             </a:ln>
           </p:spPr>
           <p:txBody>
-            <a:bodyPr wrap="none" lIns="0" tIns="0" rIns="0" bIns="0" anchor="t" anchorCtr="0">
+            <a:bodyPr wrap="square" lIns="0" tIns="0" rIns="0" bIns="0" anchor="t" anchorCtr="0">
               <a:spAutoFit/>
             </a:bodyPr>
             <a:lstStyle/>
@@ -10719,7 +10791,7 @@
           <p:spPr>
             <a:xfrm>
               <a:off x="1019556" y="4248150"/>
-              <a:ext cx="2216734" cy="656844"/>
+              <a:ext cx="2961417" cy="656844"/>
             </a:xfrm>
             <a:prstGeom prst="rect">
               <a:avLst/>
@@ -10730,7 +10802,7 @@
             </a:ln>
           </p:spPr>
           <p:txBody>
-            <a:bodyPr wrap="none" lIns="0" tIns="0" rIns="0" bIns="0" anchor="t" anchorCtr="0">
+            <a:bodyPr wrap="square" lIns="0" tIns="0" rIns="0" bIns="0" anchor="t" anchorCtr="0">
               <a:spAutoFit/>
             </a:bodyPr>
             <a:lstStyle/>
@@ -10820,7 +10892,7 @@
           <p:spPr>
             <a:xfrm>
               <a:off x="1022604" y="5346700"/>
-              <a:ext cx="1528511" cy="463296"/>
+              <a:ext cx="2101138" cy="463296"/>
             </a:xfrm>
             <a:prstGeom prst="rect">
               <a:avLst/>
@@ -10831,7 +10903,7 @@
             </a:ln>
           </p:spPr>
           <p:txBody>
-            <a:bodyPr wrap="none" lIns="0" tIns="0" rIns="0" bIns="0" anchor="t" anchorCtr="0">
+            <a:bodyPr wrap="square" lIns="0" tIns="0" rIns="0" bIns="0" anchor="t" anchorCtr="0">
               <a:spAutoFit/>
             </a:bodyPr>
             <a:lstStyle/>
@@ -10914,7 +10986,7 @@
             <p:spPr>
               <a:xfrm>
                 <a:off x="5058918" y="2044700"/>
-                <a:ext cx="85530" cy="322707"/>
+                <a:ext cx="292953" cy="322707"/>
               </a:xfrm>
               <a:prstGeom prst="rect">
                 <a:avLst/>
@@ -10925,7 +10997,7 @@
               </a:ln>
             </p:spPr>
             <p:txBody>
-              <a:bodyPr wrap="none" lIns="0" tIns="0" rIns="0" bIns="0" anchor="t" anchorCtr="0">
+              <a:bodyPr wrap="square" lIns="0" tIns="0" rIns="0" bIns="0" anchor="t" anchorCtr="0">
                 <a:spAutoFit/>
               </a:bodyPr>
               <a:lstStyle/>
@@ -10954,7 +11026,7 @@
             <p:spPr>
               <a:xfrm>
                 <a:off x="5440299" y="2057400"/>
-                <a:ext cx="2754348" cy="308991"/>
+                <a:ext cx="3633435" cy="308991"/>
               </a:xfrm>
               <a:prstGeom prst="rect">
                 <a:avLst/>
@@ -10965,7 +11037,7 @@
               </a:ln>
             </p:spPr>
             <p:txBody>
-              <a:bodyPr wrap="none" lIns="0" tIns="0" rIns="0" bIns="0" anchor="t" anchorCtr="0">
+              <a:bodyPr wrap="square" lIns="0" tIns="0" rIns="0" bIns="0" anchor="t" anchorCtr="0">
                 <a:spAutoFit/>
               </a:bodyPr>
               <a:lstStyle/>
@@ -10994,7 +11066,7 @@
             <p:spPr>
               <a:xfrm>
                 <a:off x="5441442" y="2368550"/>
-                <a:ext cx="4955352" cy="264033"/>
+                <a:ext cx="6384690" cy="264033"/>
               </a:xfrm>
               <a:prstGeom prst="rect">
                 <a:avLst/>
@@ -11005,7 +11077,7 @@
               </a:ln>
             </p:spPr>
             <p:txBody>
-              <a:bodyPr wrap="none" lIns="0" tIns="0" rIns="0" bIns="0" anchor="t" anchorCtr="0">
+              <a:bodyPr wrap="square" lIns="0" tIns="0" rIns="0" bIns="0" anchor="t" anchorCtr="0">
                 <a:spAutoFit/>
               </a:bodyPr>
               <a:lstStyle/>
@@ -11085,7 +11157,7 @@
             <p:spPr>
               <a:xfrm>
                 <a:off x="5058918" y="3092450"/>
-                <a:ext cx="154296" cy="322707"/>
+                <a:ext cx="374451" cy="322707"/>
               </a:xfrm>
               <a:prstGeom prst="rect">
                 <a:avLst/>
@@ -11096,7 +11168,7 @@
               </a:ln>
             </p:spPr>
             <p:txBody>
-              <a:bodyPr wrap="none" lIns="0" tIns="0" rIns="0" bIns="0" anchor="t" anchorCtr="0">
+              <a:bodyPr wrap="square" lIns="0" tIns="0" rIns="0" bIns="0" anchor="t" anchorCtr="0">
                 <a:spAutoFit/>
               </a:bodyPr>
               <a:lstStyle/>
@@ -11125,7 +11197,7 @@
             <p:spPr>
               <a:xfrm>
                 <a:off x="5440299" y="3105150"/>
-                <a:ext cx="3749005" cy="308991"/>
+                <a:ext cx="4876756" cy="308991"/>
               </a:xfrm>
               <a:prstGeom prst="rect">
                 <a:avLst/>
@@ -11136,7 +11208,7 @@
               </a:ln>
             </p:spPr>
             <p:txBody>
-              <a:bodyPr wrap="none" lIns="0" tIns="0" rIns="0" bIns="0" anchor="t" anchorCtr="0">
+              <a:bodyPr wrap="square" lIns="0" tIns="0" rIns="0" bIns="0" anchor="t" anchorCtr="0">
                 <a:spAutoFit/>
               </a:bodyPr>
               <a:lstStyle/>
@@ -11165,7 +11237,7 @@
             <p:spPr>
               <a:xfrm>
                 <a:off x="5441442" y="3416300"/>
-                <a:ext cx="5329040" cy="264033"/>
+                <a:ext cx="6851800" cy="264033"/>
               </a:xfrm>
               <a:prstGeom prst="rect">
                 <a:avLst/>
@@ -11176,7 +11248,7 @@
               </a:ln>
             </p:spPr>
             <p:txBody>
-              <a:bodyPr wrap="none" lIns="0" tIns="0" rIns="0" bIns="0" anchor="t" anchorCtr="0">
+              <a:bodyPr wrap="square" lIns="0" tIns="0" rIns="0" bIns="0" anchor="t" anchorCtr="0">
                 <a:spAutoFit/>
               </a:bodyPr>
               <a:lstStyle/>
@@ -11256,7 +11328,7 @@
             <p:spPr>
               <a:xfrm>
                 <a:off x="5058918" y="4140200"/>
-                <a:ext cx="223062" cy="322707"/>
+                <a:ext cx="455950" cy="322707"/>
               </a:xfrm>
               <a:prstGeom prst="rect">
                 <a:avLst/>
@@ -11267,7 +11339,7 @@
               </a:ln>
             </p:spPr>
             <p:txBody>
-              <a:bodyPr wrap="none" lIns="0" tIns="0" rIns="0" bIns="0" anchor="t" anchorCtr="0">
+              <a:bodyPr wrap="square" lIns="0" tIns="0" rIns="0" bIns="0" anchor="t" anchorCtr="0">
                 <a:spAutoFit/>
               </a:bodyPr>
               <a:lstStyle/>
@@ -11296,7 +11368,7 @@
             <p:spPr>
               <a:xfrm>
                 <a:off x="5440299" y="4152900"/>
-                <a:ext cx="2840032" cy="308991"/>
+                <a:ext cx="3740540" cy="308991"/>
               </a:xfrm>
               <a:prstGeom prst="rect">
                 <a:avLst/>
@@ -11307,7 +11379,7 @@
               </a:ln>
             </p:spPr>
             <p:txBody>
-              <a:bodyPr wrap="none" lIns="0" tIns="0" rIns="0" bIns="0" anchor="t" anchorCtr="0">
+              <a:bodyPr wrap="square" lIns="0" tIns="0" rIns="0" bIns="0" anchor="t" anchorCtr="0">
                 <a:spAutoFit/>
               </a:bodyPr>
               <a:lstStyle/>
@@ -11336,7 +11408,7 @@
             <p:spPr>
               <a:xfrm>
                 <a:off x="5441442" y="4464050"/>
-                <a:ext cx="5050929" cy="264033"/>
+                <a:ext cx="6504161" cy="264033"/>
               </a:xfrm>
               <a:prstGeom prst="rect">
                 <a:avLst/>
@@ -11347,7 +11419,7 @@
               </a:ln>
             </p:spPr>
             <p:txBody>
-              <a:bodyPr wrap="none" lIns="0" tIns="0" rIns="0" bIns="0" anchor="t" anchorCtr="0">
+              <a:bodyPr wrap="square" lIns="0" tIns="0" rIns="0" bIns="0" anchor="t" anchorCtr="0">
                 <a:spAutoFit/>
               </a:bodyPr>
               <a:lstStyle/>
@@ -11427,7 +11499,7 @@
             <p:spPr>
               <a:xfrm>
                 <a:off x="5058918" y="5187950"/>
-                <a:ext cx="202080" cy="322707"/>
+                <a:ext cx="439638" cy="322707"/>
               </a:xfrm>
               <a:prstGeom prst="rect">
                 <a:avLst/>
@@ -11438,7 +11510,7 @@
               </a:ln>
             </p:spPr>
             <p:txBody>
-              <a:bodyPr wrap="none" lIns="0" tIns="0" rIns="0" bIns="0" anchor="t" anchorCtr="0">
+              <a:bodyPr wrap="square" lIns="0" tIns="0" rIns="0" bIns="0" anchor="t" anchorCtr="0">
                 <a:spAutoFit/>
               </a:bodyPr>
               <a:lstStyle/>
@@ -11467,7 +11539,7 @@
             <p:spPr>
               <a:xfrm>
                 <a:off x="5440299" y="5200650"/>
-                <a:ext cx="3202161" cy="308991"/>
+                <a:ext cx="4193201" cy="308991"/>
               </a:xfrm>
               <a:prstGeom prst="rect">
                 <a:avLst/>
@@ -11478,7 +11550,7 @@
               </a:ln>
             </p:spPr>
             <p:txBody>
-              <a:bodyPr wrap="none" lIns="0" tIns="0" rIns="0" bIns="0" anchor="t" anchorCtr="0">
+              <a:bodyPr wrap="square" lIns="0" tIns="0" rIns="0" bIns="0" anchor="t" anchorCtr="0">
                 <a:spAutoFit/>
               </a:bodyPr>
               <a:lstStyle/>
@@ -11507,7 +11579,7 @@
             <p:spPr>
               <a:xfrm>
                 <a:off x="5441442" y="5511800"/>
-                <a:ext cx="4676473" cy="264033"/>
+                <a:ext cx="6036091" cy="264033"/>
               </a:xfrm>
               <a:prstGeom prst="rect">
                 <a:avLst/>
@@ -11518,7 +11590,7 @@
               </a:ln>
             </p:spPr>
             <p:txBody>
-              <a:bodyPr wrap="none" lIns="0" tIns="0" rIns="0" bIns="0" anchor="t" anchorCtr="0">
+              <a:bodyPr wrap="square" lIns="0" tIns="0" rIns="0" bIns="0" anchor="t" anchorCtr="0">
                 <a:spAutoFit/>
               </a:bodyPr>
               <a:lstStyle/>
@@ -11563,7 +11635,7 @@
           <p:spPr>
             <a:xfrm>
               <a:off x="603123" y="6419850"/>
-              <a:ext cx="547229" cy="250317"/>
+              <a:ext cx="839435" cy="250317"/>
             </a:xfrm>
             <a:prstGeom prst="rect">
               <a:avLst/>
@@ -11574,7 +11646,7 @@
             </a:ln>
           </p:spPr>
           <p:txBody>
-            <a:bodyPr wrap="none" lIns="0" tIns="0" rIns="0" bIns="0" anchor="t" anchorCtr="0">
+            <a:bodyPr wrap="square" lIns="0" tIns="0" rIns="0" bIns="0" anchor="t" anchorCtr="0">
               <a:spAutoFit/>
             </a:bodyPr>
             <a:lstStyle/>
@@ -11603,7 +11675,7 @@
           <p:spPr>
             <a:xfrm>
               <a:off x="1195197" y="6435725"/>
-              <a:ext cx="2013363" cy="191643"/>
+              <a:ext cx="2707203" cy="191643"/>
             </a:xfrm>
             <a:prstGeom prst="rect">
               <a:avLst/>
@@ -11614,7 +11686,7 @@
             </a:ln>
           </p:spPr>
           <p:txBody>
-            <a:bodyPr wrap="none" lIns="0" tIns="0" rIns="0" bIns="0" anchor="t" anchorCtr="0">
+            <a:bodyPr wrap="square" lIns="0" tIns="0" rIns="0" bIns="0" anchor="t" anchorCtr="0">
               <a:spAutoFit/>
             </a:bodyPr>
             <a:lstStyle/>
@@ -11636,22 +11708,34 @@
         </p:sp>
         <p:sp>
           <p:nvSpPr>
-            <p:cNvPr id="34" name="Rectangle 34"/>
+            <p:cNvPr id="34" name="Line 34"/>
             <p:cNvSpPr/>
             <p:nvPr/>
           </p:nvSpPr>
           <p:spPr>
             <a:xfrm>
-              <a:off x="11220450" y="6419850"/>
-              <a:ext cx="104775" cy="171450"/>
-            </a:xfrm>
-            <a:prstGeom prst="roundRect">
-              <a:avLst>
-                <a:gd name="adj" fmla="val 18182"/>
-              </a:avLst>
-            </a:prstGeom>
-            <a:noFill/>
-            <a:ln w="14288">
+              <a:off x="11068050" y="6515100"/>
+              <a:ext cx="190500" cy="9525"/>
+            </a:xfrm>
+            <a:custGeom>
+              <a:avLst/>
+              <a:gdLst/>
+              <a:ahLst/>
+              <a:cxnLst/>
+              <a:rect l="l" t="t" r="r" b="b"/>
+              <a:pathLst>
+                <a:path w="190500" h="9525">
+                  <a:moveTo>
+                    <a:pt x="0" y="0"/>
+                  </a:moveTo>
+                  <a:lnTo>
+                    <a:pt x="190500" y="0"/>
+                  </a:lnTo>
+                </a:path>
+              </a:pathLst>
+            </a:custGeom>
+            <a:noFill/>
+            <a:ln w="19050">
               <a:solidFill>
                 <a:srgbClr val="A8743A"/>
               </a:solidFill>
@@ -11666,8 +11750,8 @@
           </p:nvSpPr>
           <p:spPr>
             <a:xfrm>
-              <a:off x="11361138" y="6419850"/>
-              <a:ext cx="227739" cy="250317"/>
+              <a:off x="11154601" y="6419850"/>
+              <a:ext cx="434276" cy="250317"/>
             </a:xfrm>
             <a:prstGeom prst="rect">
               <a:avLst/>
@@ -11678,7 +11762,7 @@
             </a:ln>
           </p:spPr>
           <p:txBody>
-            <a:bodyPr wrap="none" lIns="0" tIns="0" rIns="0" bIns="0" anchor="t" anchorCtr="0">
+            <a:bodyPr wrap="square" lIns="0" tIns="0" rIns="0" bIns="0" anchor="t" anchorCtr="0">
               <a:spAutoFit/>
             </a:bodyPr>
             <a:lstStyle/>
@@ -11744,9 +11828,9 @@
         <p:grpSpPr>
           <a:xfrm>
             <a:off x="594360" y="565150"/>
-            <a:ext cx="8267927" cy="1118870"/>
+            <a:ext cx="7494818" cy="1118870"/>
             <a:chOff x="594360" y="565150"/>
-            <a:chExt cx="8267927" cy="1118870"/>
+            <a:chExt cx="7494818" cy="1118870"/>
           </a:xfrm>
         </p:grpSpPr>
         <p:sp>
@@ -11758,7 +11842,7 @@
           <p:spPr>
             <a:xfrm>
               <a:off x="603885" y="565150"/>
-              <a:ext cx="1349160" cy="220028"/>
+              <a:ext cx="1876950" cy="220028"/>
             </a:xfrm>
             <a:prstGeom prst="rect">
               <a:avLst/>
@@ -11769,7 +11853,7 @@
             </a:ln>
           </p:spPr>
           <p:txBody>
-            <a:bodyPr wrap="none" lIns="0" tIns="0" rIns="0" bIns="0" anchor="t" anchorCtr="0">
+            <a:bodyPr wrap="square" lIns="0" tIns="0" rIns="0" bIns="0" anchor="t" anchorCtr="0">
               <a:spAutoFit/>
             </a:bodyPr>
             <a:lstStyle/>
@@ -11798,7 +11882,7 @@
           <p:spPr>
             <a:xfrm>
               <a:off x="594360" y="850900"/>
-              <a:ext cx="8267927" cy="586740"/>
+              <a:ext cx="9559022" cy="586740"/>
             </a:xfrm>
             <a:prstGeom prst="rect">
               <a:avLst/>
@@ -11809,7 +11893,7 @@
             </a:ln>
           </p:spPr>
           <p:txBody>
-            <a:bodyPr wrap="none" lIns="0" tIns="0" rIns="0" bIns="0" anchor="t" anchorCtr="0">
+            <a:bodyPr wrap="square" lIns="0" tIns="0" rIns="0" bIns="0" anchor="t" anchorCtr="0">
               <a:spAutoFit/>
             </a:bodyPr>
             <a:lstStyle/>
@@ -11838,7 +11922,7 @@
           <p:spPr>
             <a:xfrm>
               <a:off x="601980" y="1390650"/>
-              <a:ext cx="6363682" cy="293370"/>
+              <a:ext cx="8145102" cy="293370"/>
             </a:xfrm>
             <a:prstGeom prst="rect">
               <a:avLst/>
@@ -11849,7 +11933,7 @@
             </a:ln>
           </p:spPr>
           <p:txBody>
-            <a:bodyPr wrap="none" lIns="0" tIns="0" rIns="0" bIns="0" anchor="t" anchorCtr="0">
+            <a:bodyPr wrap="square" lIns="0" tIns="0" rIns="0" bIns="0" anchor="t" anchorCtr="0">
               <a:spAutoFit/>
             </a:bodyPr>
             <a:lstStyle/>
@@ -11963,7 +12047,7 @@
           <p:spPr>
             <a:xfrm>
               <a:off x="865632" y="2184400"/>
-              <a:ext cx="878606" cy="410718"/>
+              <a:ext cx="1162611" cy="410718"/>
             </a:xfrm>
             <a:prstGeom prst="rect">
               <a:avLst/>
@@ -11974,7 +12058,7 @@
             </a:ln>
           </p:spPr>
           <p:txBody>
-            <a:bodyPr wrap="none" lIns="0" tIns="0" rIns="0" bIns="0" anchor="t" anchorCtr="0">
+            <a:bodyPr wrap="square" lIns="0" tIns="0" rIns="0" bIns="0" anchor="t" anchorCtr="0">
               <a:spAutoFit/>
             </a:bodyPr>
             <a:lstStyle/>
@@ -12003,7 +12087,7 @@
           <p:spPr>
             <a:xfrm>
               <a:off x="869823" y="2590800"/>
-              <a:ext cx="1531320" cy="250317"/>
+              <a:ext cx="2104650" cy="250317"/>
             </a:xfrm>
             <a:prstGeom prst="rect">
               <a:avLst/>
@@ -12014,7 +12098,7 @@
             </a:ln>
           </p:spPr>
           <p:txBody>
-            <a:bodyPr wrap="none" lIns="0" tIns="0" rIns="0" bIns="0" anchor="t" anchorCtr="0">
+            <a:bodyPr wrap="square" lIns="0" tIns="0" rIns="0" bIns="0" anchor="t" anchorCtr="0">
               <a:spAutoFit/>
             </a:bodyPr>
             <a:lstStyle/>
@@ -12043,7 +12127,7 @@
           <p:spPr>
             <a:xfrm>
               <a:off x="861822" y="3168650"/>
-              <a:ext cx="1630256" cy="557403"/>
+              <a:ext cx="2228320" cy="557403"/>
             </a:xfrm>
             <a:prstGeom prst="rect">
               <a:avLst/>
@@ -12054,7 +12138,7 @@
             </a:ln>
           </p:spPr>
           <p:txBody>
-            <a:bodyPr wrap="none" lIns="0" tIns="0" rIns="0" bIns="0" anchor="t" anchorCtr="0">
+            <a:bodyPr wrap="square" lIns="0" tIns="0" rIns="0" bIns="0" anchor="t" anchorCtr="0">
               <a:spAutoFit/>
             </a:bodyPr>
             <a:lstStyle/>
@@ -12119,7 +12203,7 @@
           <p:spPr>
             <a:xfrm>
               <a:off x="868680" y="4000500"/>
-              <a:ext cx="610207" cy="293370"/>
+              <a:ext cx="953258" cy="293370"/>
             </a:xfrm>
             <a:prstGeom prst="rect">
               <a:avLst/>
@@ -12130,7 +12214,7 @@
             </a:ln>
           </p:spPr>
           <p:txBody>
-            <a:bodyPr wrap="none" lIns="0" tIns="0" rIns="0" bIns="0" anchor="t" anchorCtr="0">
+            <a:bodyPr wrap="square" lIns="0" tIns="0" rIns="0" bIns="0" anchor="t" anchorCtr="0">
               <a:spAutoFit/>
             </a:bodyPr>
             <a:lstStyle/>
@@ -12170,7 +12254,7 @@
           <p:spPr>
             <a:xfrm>
               <a:off x="868680" y="4324350"/>
-              <a:ext cx="902399" cy="293370"/>
+              <a:ext cx="1318498" cy="293370"/>
             </a:xfrm>
             <a:prstGeom prst="rect">
               <a:avLst/>
@@ -12181,7 +12265,7 @@
             </a:ln>
           </p:spPr>
           <p:txBody>
-            <a:bodyPr wrap="none" lIns="0" tIns="0" rIns="0" bIns="0" anchor="t" anchorCtr="0">
+            <a:bodyPr wrap="square" lIns="0" tIns="0" rIns="0" bIns="0" anchor="t" anchorCtr="0">
               <a:spAutoFit/>
             </a:bodyPr>
             <a:lstStyle/>
@@ -12284,7 +12368,7 @@
           <p:spPr>
             <a:xfrm>
               <a:off x="3665982" y="2184400"/>
-              <a:ext cx="1267448" cy="410718"/>
+              <a:ext cx="1579937" cy="410718"/>
             </a:xfrm>
             <a:prstGeom prst="rect">
               <a:avLst/>
@@ -12295,7 +12379,7 @@
             </a:ln>
           </p:spPr>
           <p:txBody>
-            <a:bodyPr wrap="none" lIns="0" tIns="0" rIns="0" bIns="0" anchor="t" anchorCtr="0">
+            <a:bodyPr wrap="square" lIns="0" tIns="0" rIns="0" bIns="0" anchor="t" anchorCtr="0">
               <a:spAutoFit/>
             </a:bodyPr>
             <a:lstStyle/>
@@ -12324,7 +12408,7 @@
           <p:spPr>
             <a:xfrm>
               <a:off x="3670173" y="2590800"/>
-              <a:ext cx="1818382" cy="250317"/>
+              <a:ext cx="2463477" cy="250317"/>
             </a:xfrm>
             <a:prstGeom prst="rect">
               <a:avLst/>
@@ -12335,7 +12419,7 @@
             </a:ln>
           </p:spPr>
           <p:txBody>
-            <a:bodyPr wrap="none" lIns="0" tIns="0" rIns="0" bIns="0" anchor="t" anchorCtr="0">
+            <a:bodyPr wrap="square" lIns="0" tIns="0" rIns="0" bIns="0" anchor="t" anchorCtr="0">
               <a:spAutoFit/>
             </a:bodyPr>
             <a:lstStyle/>
@@ -12364,7 +12448,7 @@
           <p:spPr>
             <a:xfrm>
               <a:off x="3662172" y="3168650"/>
-              <a:ext cx="1630256" cy="557403"/>
+              <a:ext cx="2228320" cy="557403"/>
             </a:xfrm>
             <a:prstGeom prst="rect">
               <a:avLst/>
@@ -12375,7 +12459,7 @@
             </a:ln>
           </p:spPr>
           <p:txBody>
-            <a:bodyPr wrap="none" lIns="0" tIns="0" rIns="0" bIns="0" anchor="t" anchorCtr="0">
+            <a:bodyPr wrap="square" lIns="0" tIns="0" rIns="0" bIns="0" anchor="t" anchorCtr="0">
               <a:spAutoFit/>
             </a:bodyPr>
             <a:lstStyle/>
@@ -12440,7 +12524,7 @@
           <p:spPr>
             <a:xfrm>
               <a:off x="3669030" y="4000500"/>
-              <a:ext cx="722520" cy="293370"/>
+              <a:ext cx="1093650" cy="293370"/>
             </a:xfrm>
             <a:prstGeom prst="rect">
               <a:avLst/>
@@ -12451,7 +12535,7 @@
             </a:ln>
           </p:spPr>
           <p:txBody>
-            <a:bodyPr wrap="none" lIns="0" tIns="0" rIns="0" bIns="0" anchor="t" anchorCtr="0">
+            <a:bodyPr wrap="square" lIns="0" tIns="0" rIns="0" bIns="0" anchor="t" anchorCtr="0">
               <a:spAutoFit/>
             </a:bodyPr>
             <a:lstStyle/>
@@ -12491,7 +12575,7 @@
           <p:spPr>
             <a:xfrm>
               <a:off x="3669030" y="4324350"/>
-              <a:ext cx="1014713" cy="293370"/>
+              <a:ext cx="1458891" cy="293370"/>
             </a:xfrm>
             <a:prstGeom prst="rect">
               <a:avLst/>
@@ -12502,7 +12586,7 @@
             </a:ln>
           </p:spPr>
           <p:txBody>
-            <a:bodyPr wrap="none" lIns="0" tIns="0" rIns="0" bIns="0" anchor="t" anchorCtr="0">
+            <a:bodyPr wrap="square" lIns="0" tIns="0" rIns="0" bIns="0" anchor="t" anchorCtr="0">
               <a:spAutoFit/>
             </a:bodyPr>
             <a:lstStyle/>
@@ -12605,7 +12689,7 @@
           <p:spPr>
             <a:xfrm>
               <a:off x="6466332" y="2184400"/>
-              <a:ext cx="1501979" cy="410718"/>
+              <a:ext cx="1901120" cy="410718"/>
             </a:xfrm>
             <a:prstGeom prst="rect">
               <a:avLst/>
@@ -12616,7 +12700,7 @@
             </a:ln>
           </p:spPr>
           <p:txBody>
-            <a:bodyPr wrap="none" lIns="0" tIns="0" rIns="0" bIns="0" anchor="t" anchorCtr="0">
+            <a:bodyPr wrap="square" lIns="0" tIns="0" rIns="0" bIns="0" anchor="t" anchorCtr="0">
               <a:spAutoFit/>
             </a:bodyPr>
             <a:lstStyle/>
@@ -12645,7 +12729,7 @@
           <p:spPr>
             <a:xfrm>
               <a:off x="6470523" y="2590800"/>
-              <a:ext cx="1885809" cy="250317"/>
+              <a:ext cx="2547761" cy="250317"/>
             </a:xfrm>
             <a:prstGeom prst="rect">
               <a:avLst/>
@@ -12656,7 +12740,7 @@
             </a:ln>
           </p:spPr>
           <p:txBody>
-            <a:bodyPr wrap="none" lIns="0" tIns="0" rIns="0" bIns="0" anchor="t" anchorCtr="0">
+            <a:bodyPr wrap="square" lIns="0" tIns="0" rIns="0" bIns="0" anchor="t" anchorCtr="0">
               <a:spAutoFit/>
             </a:bodyPr>
             <a:lstStyle/>
@@ -12685,7 +12769,7 @@
           <p:spPr>
             <a:xfrm>
               <a:off x="6462522" y="3168650"/>
-              <a:ext cx="1630256" cy="557403"/>
+              <a:ext cx="2228320" cy="557403"/>
             </a:xfrm>
             <a:prstGeom prst="rect">
               <a:avLst/>
@@ -12696,7 +12780,7 @@
             </a:ln>
           </p:spPr>
           <p:txBody>
-            <a:bodyPr wrap="none" lIns="0" tIns="0" rIns="0" bIns="0" anchor="t" anchorCtr="0">
+            <a:bodyPr wrap="square" lIns="0" tIns="0" rIns="0" bIns="0" anchor="t" anchorCtr="0">
               <a:spAutoFit/>
             </a:bodyPr>
             <a:lstStyle/>
@@ -12761,7 +12845,7 @@
           <p:spPr>
             <a:xfrm>
               <a:off x="6469380" y="4000500"/>
-              <a:ext cx="722520" cy="293370"/>
+              <a:ext cx="1093650" cy="293370"/>
             </a:xfrm>
             <a:prstGeom prst="rect">
               <a:avLst/>
@@ -12772,7 +12856,7 @@
             </a:ln>
           </p:spPr>
           <p:txBody>
-            <a:bodyPr wrap="none" lIns="0" tIns="0" rIns="0" bIns="0" anchor="t" anchorCtr="0">
+            <a:bodyPr wrap="square" lIns="0" tIns="0" rIns="0" bIns="0" anchor="t" anchorCtr="0">
               <a:spAutoFit/>
             </a:bodyPr>
             <a:lstStyle/>
@@ -12812,7 +12896,7 @@
           <p:spPr>
             <a:xfrm>
               <a:off x="6469380" y="4324350"/>
-              <a:ext cx="1014713" cy="293370"/>
+              <a:ext cx="1458891" cy="293370"/>
             </a:xfrm>
             <a:prstGeom prst="rect">
               <a:avLst/>
@@ -12823,7 +12907,7 @@
             </a:ln>
           </p:spPr>
           <p:txBody>
-            <a:bodyPr wrap="none" lIns="0" tIns="0" rIns="0" bIns="0" anchor="t" anchorCtr="0">
+            <a:bodyPr wrap="square" lIns="0" tIns="0" rIns="0" bIns="0" anchor="t" anchorCtr="0">
               <a:spAutoFit/>
             </a:bodyPr>
             <a:lstStyle/>
@@ -12924,7 +13008,7 @@
           <p:spPr>
             <a:xfrm>
               <a:off x="9266682" y="2184400"/>
-              <a:ext cx="1849158" cy="410718"/>
+              <a:ext cx="2314002" cy="410718"/>
             </a:xfrm>
             <a:prstGeom prst="rect">
               <a:avLst/>
@@ -12935,7 +13019,7 @@
             </a:ln>
           </p:spPr>
           <p:txBody>
-            <a:bodyPr wrap="none" lIns="0" tIns="0" rIns="0" bIns="0" anchor="t" anchorCtr="0">
+            <a:bodyPr wrap="square" lIns="0" tIns="0" rIns="0" bIns="0" anchor="t" anchorCtr="0">
               <a:spAutoFit/>
             </a:bodyPr>
             <a:lstStyle/>
@@ -12964,7 +13048,7 @@
           <p:spPr>
             <a:xfrm>
               <a:off x="9270873" y="2590800"/>
-              <a:ext cx="1713111" cy="250317"/>
+              <a:ext cx="2331888" cy="250317"/>
             </a:xfrm>
             <a:prstGeom prst="rect">
               <a:avLst/>
@@ -12975,7 +13059,7 @@
             </a:ln>
           </p:spPr>
           <p:txBody>
-            <a:bodyPr wrap="none" lIns="0" tIns="0" rIns="0" bIns="0" anchor="t" anchorCtr="0">
+            <a:bodyPr wrap="square" lIns="0" tIns="0" rIns="0" bIns="0" anchor="t" anchorCtr="0">
               <a:spAutoFit/>
             </a:bodyPr>
             <a:lstStyle/>
@@ -13004,7 +13088,7 @@
           <p:spPr>
             <a:xfrm>
               <a:off x="9271254" y="2990850"/>
-              <a:ext cx="335280" cy="234696"/>
+              <a:ext cx="609600" cy="234696"/>
             </a:xfrm>
             <a:prstGeom prst="rect">
               <a:avLst/>
@@ -13015,7 +13099,7 @@
             </a:ln>
           </p:spPr>
           <p:txBody>
-            <a:bodyPr wrap="none" lIns="0" tIns="0" rIns="0" bIns="0" anchor="t" anchorCtr="0">
+            <a:bodyPr wrap="square" lIns="0" tIns="0" rIns="0" bIns="0" anchor="t" anchorCtr="0">
               <a:spAutoFit/>
             </a:bodyPr>
             <a:lstStyle/>
@@ -13044,7 +13128,7 @@
           <p:spPr>
             <a:xfrm>
               <a:off x="9262872" y="3168650"/>
-              <a:ext cx="1849691" cy="557403"/>
+              <a:ext cx="2502613" cy="557403"/>
             </a:xfrm>
             <a:prstGeom prst="rect">
               <a:avLst/>
@@ -13055,7 +13139,7 @@
             </a:ln>
           </p:spPr>
           <p:txBody>
-            <a:bodyPr wrap="none" lIns="0" tIns="0" rIns="0" bIns="0" anchor="t" anchorCtr="0">
+            <a:bodyPr wrap="square" lIns="0" tIns="0" rIns="0" bIns="0" anchor="t" anchorCtr="0">
               <a:spAutoFit/>
             </a:bodyPr>
             <a:lstStyle/>
@@ -13120,7 +13204,7 @@
           <p:spPr>
             <a:xfrm>
               <a:off x="9269730" y="3937000"/>
-              <a:ext cx="1815655" cy="617220"/>
+              <a:ext cx="2460068" cy="617220"/>
             </a:xfrm>
             <a:prstGeom prst="rect">
               <a:avLst/>
@@ -13131,7 +13215,7 @@
             </a:ln>
           </p:spPr>
           <p:txBody>
-            <a:bodyPr wrap="none" lIns="0" tIns="0" rIns="0" bIns="0" anchor="t" anchorCtr="0">
+            <a:bodyPr wrap="square" lIns="0" tIns="0" rIns="0" bIns="0" anchor="t" anchorCtr="0">
               <a:spAutoFit/>
             </a:bodyPr>
             <a:lstStyle/>
@@ -13224,7 +13308,7 @@
           <p:spPr>
             <a:xfrm>
               <a:off x="870966" y="5207000"/>
-              <a:ext cx="1816223" cy="205359"/>
+              <a:ext cx="2460778" cy="205359"/>
             </a:xfrm>
             <a:prstGeom prst="rect">
               <a:avLst/>
@@ -13235,7 +13319,7 @@
             </a:ln>
           </p:spPr>
           <p:txBody>
-            <a:bodyPr wrap="none" lIns="0" tIns="0" rIns="0" bIns="0" anchor="t" anchorCtr="0">
+            <a:bodyPr wrap="square" lIns="0" tIns="0" rIns="0" bIns="0" anchor="t" anchorCtr="0">
               <a:spAutoFit/>
             </a:bodyPr>
             <a:lstStyle/>
@@ -13263,8 +13347,8 @@
           </p:nvSpPr>
           <p:spPr>
             <a:xfrm>
-              <a:off x="870204" y="5448300"/>
-              <a:ext cx="7344701" cy="234696"/>
+              <a:off x="869061" y="5441950"/>
+              <a:ext cx="11054600" cy="278702"/>
             </a:xfrm>
             <a:prstGeom prst="rect">
               <a:avLst/>
@@ -13275,14 +13359,14 @@
             </a:ln>
           </p:spPr>
           <p:txBody>
-            <a:bodyPr wrap="none" lIns="0" tIns="0" rIns="0" bIns="0" anchor="t" anchorCtr="0">
+            <a:bodyPr wrap="square" lIns="0" tIns="0" rIns="0" bIns="0" anchor="t" anchorCtr="0">
               <a:spAutoFit/>
             </a:bodyPr>
             <a:lstStyle/>
             <a:p>
               <a:pPr algn="l"/>
               <a:r>
-                <a:rPr lang="en" sz="1200" dirty="0">
+                <a:rPr lang="en" sz="1420" dirty="0">
                   <a:solidFill>
                     <a:srgbClr val="5C6461"/>
                   </a:solidFill>
@@ -13319,7 +13403,7 @@
           <p:spPr>
             <a:xfrm>
               <a:off x="603123" y="6419850"/>
-              <a:ext cx="547229" cy="250317"/>
+              <a:ext cx="839435" cy="250317"/>
             </a:xfrm>
             <a:prstGeom prst="rect">
               <a:avLst/>
@@ -13330,7 +13414,7 @@
             </a:ln>
           </p:spPr>
           <p:txBody>
-            <a:bodyPr wrap="none" lIns="0" tIns="0" rIns="0" bIns="0" anchor="t" anchorCtr="0">
+            <a:bodyPr wrap="square" lIns="0" tIns="0" rIns="0" bIns="0" anchor="t" anchorCtr="0">
               <a:spAutoFit/>
             </a:bodyPr>
             <a:lstStyle/>
@@ -13359,7 +13443,7 @@
           <p:spPr>
             <a:xfrm>
               <a:off x="1195197" y="6435725"/>
-              <a:ext cx="2013363" cy="191643"/>
+              <a:ext cx="2707203" cy="191643"/>
             </a:xfrm>
             <a:prstGeom prst="rect">
               <a:avLst/>
@@ -13370,7 +13454,7 @@
             </a:ln>
           </p:spPr>
           <p:txBody>
-            <a:bodyPr wrap="none" lIns="0" tIns="0" rIns="0" bIns="0" anchor="t" anchorCtr="0">
+            <a:bodyPr wrap="square" lIns="0" tIns="0" rIns="0" bIns="0" anchor="t" anchorCtr="0">
               <a:spAutoFit/>
             </a:bodyPr>
             <a:lstStyle/>
@@ -13392,22 +13476,34 @@
         </p:sp>
         <p:sp>
           <p:nvSpPr>
-            <p:cNvPr id="48" name="Rectangle 48"/>
+            <p:cNvPr id="48" name="Line 48"/>
             <p:cNvSpPr/>
             <p:nvPr/>
           </p:nvSpPr>
           <p:spPr>
             <a:xfrm>
-              <a:off x="11220450" y="6419850"/>
-              <a:ext cx="104775" cy="171450"/>
-            </a:xfrm>
-            <a:prstGeom prst="roundRect">
-              <a:avLst>
-                <a:gd name="adj" fmla="val 18182"/>
-              </a:avLst>
-            </a:prstGeom>
-            <a:noFill/>
-            <a:ln w="14288">
+              <a:off x="11068050" y="6515100"/>
+              <a:ext cx="190500" cy="9525"/>
+            </a:xfrm>
+            <a:custGeom>
+              <a:avLst/>
+              <a:gdLst/>
+              <a:ahLst/>
+              <a:cxnLst/>
+              <a:rect l="l" t="t" r="r" b="b"/>
+              <a:pathLst>
+                <a:path w="190500" h="9525">
+                  <a:moveTo>
+                    <a:pt x="0" y="0"/>
+                  </a:moveTo>
+                  <a:lnTo>
+                    <a:pt x="190500" y="0"/>
+                  </a:lnTo>
+                </a:path>
+              </a:pathLst>
+            </a:custGeom>
+            <a:noFill/>
+            <a:ln w="19050">
               <a:solidFill>
                 <a:srgbClr val="A8743A"/>
               </a:solidFill>
@@ -13422,8 +13518,8 @@
           </p:nvSpPr>
           <p:spPr>
             <a:xfrm>
-              <a:off x="11372700" y="6419850"/>
-              <a:ext cx="216177" cy="250317"/>
+              <a:off x="11154601" y="6419850"/>
+              <a:ext cx="434276" cy="250317"/>
             </a:xfrm>
             <a:prstGeom prst="rect">
               <a:avLst/>
@@ -13434,7 +13530,7 @@
             </a:ln>
           </p:spPr>
           <p:txBody>
-            <a:bodyPr wrap="none" lIns="0" tIns="0" rIns="0" bIns="0" anchor="t" anchorCtr="0">
+            <a:bodyPr wrap="square" lIns="0" tIns="0" rIns="0" bIns="0" anchor="t" anchorCtr="0">
               <a:spAutoFit/>
             </a:bodyPr>
             <a:lstStyle/>
@@ -13500,9 +13596,9 @@
         <p:grpSpPr>
           <a:xfrm>
             <a:off x="594360" y="565150"/>
-            <a:ext cx="8973706" cy="1118870"/>
+            <a:ext cx="8221726" cy="1118870"/>
             <a:chOff x="594360" y="565150"/>
-            <a:chExt cx="8973706" cy="1118870"/>
+            <a:chExt cx="8221726" cy="1118870"/>
           </a:xfrm>
         </p:grpSpPr>
         <p:sp>
@@ -13514,7 +13610,7 @@
           <p:spPr>
             <a:xfrm>
               <a:off x="603885" y="565150"/>
-              <a:ext cx="2812454" cy="220028"/>
+              <a:ext cx="3706067" cy="220028"/>
             </a:xfrm>
             <a:prstGeom prst="rect">
               <a:avLst/>
@@ -13525,7 +13621,7 @@
             </a:ln>
           </p:spPr>
           <p:txBody>
-            <a:bodyPr wrap="none" lIns="0" tIns="0" rIns="0" bIns="0" anchor="t" anchorCtr="0">
+            <a:bodyPr wrap="square" lIns="0" tIns="0" rIns="0" bIns="0" anchor="t" anchorCtr="0">
               <a:spAutoFit/>
             </a:bodyPr>
             <a:lstStyle/>
@@ -13554,7 +13650,7 @@
           <p:spPr>
             <a:xfrm>
               <a:off x="594360" y="850900"/>
-              <a:ext cx="8973706" cy="586740"/>
+              <a:ext cx="10467657" cy="586740"/>
             </a:xfrm>
             <a:prstGeom prst="rect">
               <a:avLst/>
@@ -13565,7 +13661,7 @@
             </a:ln>
           </p:spPr>
           <p:txBody>
-            <a:bodyPr wrap="none" lIns="0" tIns="0" rIns="0" bIns="0" anchor="t" anchorCtr="0">
+            <a:bodyPr wrap="square" lIns="0" tIns="0" rIns="0" bIns="0" anchor="t" anchorCtr="0">
               <a:spAutoFit/>
             </a:bodyPr>
             <a:lstStyle/>
@@ -13594,7 +13690,7 @@
           <p:spPr>
             <a:xfrm>
               <a:off x="601980" y="1390650"/>
-              <a:ext cx="4567809" cy="293370"/>
+              <a:ext cx="5900261" cy="293370"/>
             </a:xfrm>
             <a:prstGeom prst="rect">
               <a:avLst/>
@@ -13605,7 +13701,7 @@
             </a:ln>
           </p:spPr>
           <p:txBody>
-            <a:bodyPr wrap="none" lIns="0" tIns="0" rIns="0" bIns="0" anchor="t" anchorCtr="0">
+            <a:bodyPr wrap="square" lIns="0" tIns="0" rIns="0" bIns="0" anchor="t" anchorCtr="0">
               <a:spAutoFit/>
             </a:bodyPr>
             <a:lstStyle/>
@@ -13673,7 +13769,7 @@
           <p:spPr>
             <a:xfrm>
               <a:off x="946785" y="2260600"/>
-              <a:ext cx="2580025" cy="220028"/>
+              <a:ext cx="3415531" cy="220028"/>
             </a:xfrm>
             <a:prstGeom prst="rect">
               <a:avLst/>
@@ -13684,7 +13780,7 @@
             </a:ln>
           </p:spPr>
           <p:txBody>
-            <a:bodyPr wrap="none" lIns="0" tIns="0" rIns="0" bIns="0" anchor="t" anchorCtr="0">
+            <a:bodyPr wrap="square" lIns="0" tIns="0" rIns="0" bIns="0" anchor="t" anchorCtr="0">
               <a:spAutoFit/>
             </a:bodyPr>
             <a:lstStyle/>
@@ -13727,7 +13823,7 @@
             <p:spPr>
               <a:xfrm>
                 <a:off x="939546" y="2730500"/>
-                <a:ext cx="404398" cy="498729"/>
+                <a:ext cx="676275" cy="498729"/>
               </a:xfrm>
               <a:prstGeom prst="rect">
                 <a:avLst/>
@@ -13738,7 +13834,7 @@
               </a:ln>
             </p:spPr>
             <p:txBody>
-              <a:bodyPr wrap="none" lIns="0" tIns="0" rIns="0" bIns="0" anchor="t" anchorCtr="0">
+              <a:bodyPr wrap="square" lIns="0" tIns="0" rIns="0" bIns="0" anchor="t" anchorCtr="0">
                 <a:spAutoFit/>
               </a:bodyPr>
               <a:lstStyle/>
@@ -13767,7 +13863,7 @@
             <p:spPr>
               <a:xfrm>
                 <a:off x="944499" y="3238500"/>
-                <a:ext cx="1558679" cy="308991"/>
+                <a:ext cx="2138848" cy="308991"/>
               </a:xfrm>
               <a:prstGeom prst="rect">
                 <a:avLst/>
@@ -13778,7 +13874,7 @@
               </a:ln>
             </p:spPr>
             <p:txBody>
-              <a:bodyPr wrap="none" lIns="0" tIns="0" rIns="0" bIns="0" anchor="t" anchorCtr="0">
+              <a:bodyPr wrap="square" lIns="0" tIns="0" rIns="0" bIns="0" anchor="t" anchorCtr="0">
                 <a:spAutoFit/>
               </a:bodyPr>
               <a:lstStyle/>
@@ -13807,7 +13903,7 @@
             <p:spPr>
               <a:xfrm>
                 <a:off x="945642" y="3524250"/>
-                <a:ext cx="1643108" cy="511683"/>
+                <a:ext cx="2244385" cy="511683"/>
               </a:xfrm>
               <a:prstGeom prst="rect">
                 <a:avLst/>
@@ -13818,7 +13914,7 @@
               </a:ln>
             </p:spPr>
             <p:txBody>
-              <a:bodyPr wrap="none" lIns="0" tIns="0" rIns="0" bIns="0" anchor="t" anchorCtr="0">
+              <a:bodyPr wrap="square" lIns="0" tIns="0" rIns="0" bIns="0" anchor="t" anchorCtr="0">
                 <a:spAutoFit/>
               </a:bodyPr>
               <a:lstStyle/>
@@ -13887,7 +13983,7 @@
             <p:spPr>
               <a:xfrm>
                 <a:off x="4482846" y="2730500"/>
-                <a:ext cx="451152" cy="498729"/>
+                <a:ext cx="676275" cy="498729"/>
               </a:xfrm>
               <a:prstGeom prst="rect">
                 <a:avLst/>
@@ -13898,7 +13994,7 @@
               </a:ln>
             </p:spPr>
             <p:txBody>
-              <a:bodyPr wrap="none" lIns="0" tIns="0" rIns="0" bIns="0" anchor="t" anchorCtr="0">
+              <a:bodyPr wrap="square" lIns="0" tIns="0" rIns="0" bIns="0" anchor="t" anchorCtr="0">
                 <a:spAutoFit/>
               </a:bodyPr>
               <a:lstStyle/>
@@ -13927,7 +14023,7 @@
             <p:spPr>
               <a:xfrm>
                 <a:off x="4487799" y="3238500"/>
-                <a:ext cx="1133135" cy="308991"/>
+                <a:ext cx="1606918" cy="308991"/>
               </a:xfrm>
               <a:prstGeom prst="rect">
                 <a:avLst/>
@@ -13938,7 +14034,7 @@
               </a:ln>
             </p:spPr>
             <p:txBody>
-              <a:bodyPr wrap="none" lIns="0" tIns="0" rIns="0" bIns="0" anchor="t" anchorCtr="0">
+              <a:bodyPr wrap="square" lIns="0" tIns="0" rIns="0" bIns="0" anchor="t" anchorCtr="0">
                 <a:spAutoFit/>
               </a:bodyPr>
               <a:lstStyle/>
@@ -13967,7 +14063,7 @@
             <p:spPr>
               <a:xfrm>
                 <a:off x="4488942" y="3524250"/>
-                <a:ext cx="1653087" cy="511683"/>
+                <a:ext cx="2256858" cy="511683"/>
               </a:xfrm>
               <a:prstGeom prst="rect">
                 <a:avLst/>
@@ -13978,7 +14074,7 @@
               </a:ln>
             </p:spPr>
             <p:txBody>
-              <a:bodyPr wrap="none" lIns="0" tIns="0" rIns="0" bIns="0" anchor="t" anchorCtr="0">
+              <a:bodyPr wrap="square" lIns="0" tIns="0" rIns="0" bIns="0" anchor="t" anchorCtr="0">
                 <a:spAutoFit/>
               </a:bodyPr>
               <a:lstStyle/>
@@ -14083,7 +14179,7 @@
             <p:spPr>
               <a:xfrm>
                 <a:off x="939546" y="4502150"/>
-                <a:ext cx="448685" cy="498729"/>
+                <a:ext cx="676275" cy="498729"/>
               </a:xfrm>
               <a:prstGeom prst="rect">
                 <a:avLst/>
@@ -14094,7 +14190,7 @@
               </a:ln>
             </p:spPr>
             <p:txBody>
-              <a:bodyPr wrap="none" lIns="0" tIns="0" rIns="0" bIns="0" anchor="t" anchorCtr="0">
+              <a:bodyPr wrap="square" lIns="0" tIns="0" rIns="0" bIns="0" anchor="t" anchorCtr="0">
                 <a:spAutoFit/>
               </a:bodyPr>
               <a:lstStyle/>
@@ -14123,7 +14219,7 @@
             <p:spPr>
               <a:xfrm>
                 <a:off x="944499" y="5010150"/>
-                <a:ext cx="1938419" cy="308991"/>
+                <a:ext cx="2613523" cy="308991"/>
               </a:xfrm>
               <a:prstGeom prst="rect">
                 <a:avLst/>
@@ -14134,7 +14230,7 @@
               </a:ln>
             </p:spPr>
             <p:txBody>
-              <a:bodyPr wrap="none" lIns="0" tIns="0" rIns="0" bIns="0" anchor="t" anchorCtr="0">
+              <a:bodyPr wrap="square" lIns="0" tIns="0" rIns="0" bIns="0" anchor="t" anchorCtr="0">
                 <a:spAutoFit/>
               </a:bodyPr>
               <a:lstStyle/>
@@ -14163,7 +14259,7 @@
             <p:spPr>
               <a:xfrm>
                 <a:off x="945642" y="5295900"/>
-                <a:ext cx="1767375" cy="511683"/>
+                <a:ext cx="2399718" cy="511683"/>
               </a:xfrm>
               <a:prstGeom prst="rect">
                 <a:avLst/>
@@ -14174,7 +14270,7 @@
               </a:ln>
             </p:spPr>
             <p:txBody>
-              <a:bodyPr wrap="none" lIns="0" tIns="0" rIns="0" bIns="0" anchor="t" anchorCtr="0">
+              <a:bodyPr wrap="square" lIns="0" tIns="0" rIns="0" bIns="0" anchor="t" anchorCtr="0">
                 <a:spAutoFit/>
               </a:bodyPr>
               <a:lstStyle/>
@@ -14243,7 +14339,7 @@
             <p:spPr>
               <a:xfrm>
                 <a:off x="4482846" y="4502150"/>
-                <a:ext cx="453437" cy="498729"/>
+                <a:ext cx="676275" cy="498729"/>
               </a:xfrm>
               <a:prstGeom prst="rect">
                 <a:avLst/>
@@ -14254,7 +14350,7 @@
               </a:ln>
             </p:spPr>
             <p:txBody>
-              <a:bodyPr wrap="none" lIns="0" tIns="0" rIns="0" bIns="0" anchor="t" anchorCtr="0">
+              <a:bodyPr wrap="square" lIns="0" tIns="0" rIns="0" bIns="0" anchor="t" anchorCtr="0">
                 <a:spAutoFit/>
               </a:bodyPr>
               <a:lstStyle/>
@@ -14283,7 +14379,7 @@
             <p:spPr>
               <a:xfrm>
                 <a:off x="4487799" y="5010150"/>
-                <a:ext cx="2103521" cy="308991"/>
+                <a:ext cx="2819901" cy="308991"/>
               </a:xfrm>
               <a:prstGeom prst="rect">
                 <a:avLst/>
@@ -14294,7 +14390,7 @@
               </a:ln>
             </p:spPr>
             <p:txBody>
-              <a:bodyPr wrap="none" lIns="0" tIns="0" rIns="0" bIns="0" anchor="t" anchorCtr="0">
+              <a:bodyPr wrap="square" lIns="0" tIns="0" rIns="0" bIns="0" anchor="t" anchorCtr="0">
                 <a:spAutoFit/>
               </a:bodyPr>
               <a:lstStyle/>
@@ -14323,7 +14419,7 @@
             <p:spPr>
               <a:xfrm>
                 <a:off x="4488942" y="5295900"/>
-                <a:ext cx="1853546" cy="511683"/>
+                <a:ext cx="2507432" cy="511683"/>
               </a:xfrm>
               <a:prstGeom prst="rect">
                 <a:avLst/>
@@ -14334,7 +14430,7 @@
               </a:ln>
             </p:spPr>
             <p:txBody>
-              <a:bodyPr wrap="none" lIns="0" tIns="0" rIns="0" bIns="0" anchor="t" anchorCtr="0">
+              <a:bodyPr wrap="square" lIns="0" tIns="0" rIns="0" bIns="0" anchor="t" anchorCtr="0">
                 <a:spAutoFit/>
               </a:bodyPr>
               <a:lstStyle/>
@@ -14428,7 +14524,7 @@
           <p:spPr>
             <a:xfrm>
               <a:off x="8642985" y="2260600"/>
-              <a:ext cx="1903158" cy="220028"/>
+              <a:ext cx="2569447" cy="220028"/>
             </a:xfrm>
             <a:prstGeom prst="rect">
               <a:avLst/>
@@ -14439,7 +14535,7 @@
             </a:ln>
           </p:spPr>
           <p:txBody>
-            <a:bodyPr wrap="none" lIns="0" tIns="0" rIns="0" bIns="0" anchor="t" anchorCtr="0">
+            <a:bodyPr wrap="square" lIns="0" tIns="0" rIns="0" bIns="0" anchor="t" anchorCtr="0">
               <a:spAutoFit/>
             </a:bodyPr>
             <a:lstStyle/>
@@ -14482,7 +14578,7 @@
             <p:spPr>
               <a:xfrm>
                 <a:off x="8635746" y="2730500"/>
-                <a:ext cx="404398" cy="498729"/>
+                <a:ext cx="676275" cy="498729"/>
               </a:xfrm>
               <a:prstGeom prst="rect">
                 <a:avLst/>
@@ -14493,7 +14589,7 @@
               </a:ln>
             </p:spPr>
             <p:txBody>
-              <a:bodyPr wrap="none" lIns="0" tIns="0" rIns="0" bIns="0" anchor="t" anchorCtr="0">
+              <a:bodyPr wrap="square" lIns="0" tIns="0" rIns="0" bIns="0" anchor="t" anchorCtr="0">
                 <a:spAutoFit/>
               </a:bodyPr>
               <a:lstStyle/>
@@ -14522,7 +14618,7 @@
             <p:spPr>
               <a:xfrm>
                 <a:off x="8640699" y="3238500"/>
-                <a:ext cx="2008917" cy="308991"/>
+                <a:ext cx="2701646" cy="308991"/>
               </a:xfrm>
               <a:prstGeom prst="rect">
                 <a:avLst/>
@@ -14533,7 +14629,7 @@
               </a:ln>
             </p:spPr>
             <p:txBody>
-              <a:bodyPr wrap="none" lIns="0" tIns="0" rIns="0" bIns="0" anchor="t" anchorCtr="0">
+              <a:bodyPr wrap="square" lIns="0" tIns="0" rIns="0" bIns="0" anchor="t" anchorCtr="0">
                 <a:spAutoFit/>
               </a:bodyPr>
               <a:lstStyle/>
@@ -14562,7 +14658,7 @@
             <p:spPr>
               <a:xfrm>
                 <a:off x="8641842" y="3524250"/>
-                <a:ext cx="1424441" cy="511683"/>
+                <a:ext cx="1971051" cy="511683"/>
               </a:xfrm>
               <a:prstGeom prst="rect">
                 <a:avLst/>
@@ -14573,7 +14669,7 @@
               </a:ln>
             </p:spPr>
             <p:txBody>
-              <a:bodyPr wrap="none" lIns="0" tIns="0" rIns="0" bIns="0" anchor="t" anchorCtr="0">
+              <a:bodyPr wrap="square" lIns="0" tIns="0" rIns="0" bIns="0" anchor="t" anchorCtr="0">
                 <a:spAutoFit/>
               </a:bodyPr>
               <a:lstStyle/>
@@ -14678,7 +14774,7 @@
             <p:spPr>
               <a:xfrm>
                 <a:off x="8635746" y="4502150"/>
-                <a:ext cx="451152" cy="498729"/>
+                <a:ext cx="676275" cy="498729"/>
               </a:xfrm>
               <a:prstGeom prst="rect">
                 <a:avLst/>
@@ -14689,7 +14785,7 @@
               </a:ln>
             </p:spPr>
             <p:txBody>
-              <a:bodyPr wrap="none" lIns="0" tIns="0" rIns="0" bIns="0" anchor="t" anchorCtr="0">
+              <a:bodyPr wrap="square" lIns="0" tIns="0" rIns="0" bIns="0" anchor="t" anchorCtr="0">
                 <a:spAutoFit/>
               </a:bodyPr>
               <a:lstStyle/>
@@ -14718,7 +14814,7 @@
             <p:spPr>
               <a:xfrm>
                 <a:off x="8640699" y="5010150"/>
-                <a:ext cx="1831625" cy="308991"/>
+                <a:ext cx="2480031" cy="308991"/>
               </a:xfrm>
               <a:prstGeom prst="rect">
                 <a:avLst/>
@@ -14729,7 +14825,7 @@
               </a:ln>
             </p:spPr>
             <p:txBody>
-              <a:bodyPr wrap="none" lIns="0" tIns="0" rIns="0" bIns="0" anchor="t" anchorCtr="0">
+              <a:bodyPr wrap="square" lIns="0" tIns="0" rIns="0" bIns="0" anchor="t" anchorCtr="0">
                 <a:spAutoFit/>
               </a:bodyPr>
               <a:lstStyle/>
@@ -14758,7 +14854,7 @@
             <p:spPr>
               <a:xfrm>
                 <a:off x="8641842" y="5295900"/>
-                <a:ext cx="1881561" cy="511683"/>
+                <a:ext cx="2542451" cy="511683"/>
               </a:xfrm>
               <a:prstGeom prst="rect">
                 <a:avLst/>
@@ -14769,7 +14865,7 @@
               </a:ln>
             </p:spPr>
             <p:txBody>
-              <a:bodyPr wrap="none" lIns="0" tIns="0" rIns="0" bIns="0" anchor="t" anchorCtr="0">
+              <a:bodyPr wrap="square" lIns="0" tIns="0" rIns="0" bIns="0" anchor="t" anchorCtr="0">
                 <a:spAutoFit/>
               </a:bodyPr>
               <a:lstStyle/>
@@ -14839,7 +14935,7 @@
           <p:spPr>
             <a:xfrm>
               <a:off x="603123" y="6419850"/>
-              <a:ext cx="547229" cy="250317"/>
+              <a:ext cx="839435" cy="250317"/>
             </a:xfrm>
             <a:prstGeom prst="rect">
               <a:avLst/>
@@ -14850,7 +14946,7 @@
             </a:ln>
           </p:spPr>
           <p:txBody>
-            <a:bodyPr wrap="none" lIns="0" tIns="0" rIns="0" bIns="0" anchor="t" anchorCtr="0">
+            <a:bodyPr wrap="square" lIns="0" tIns="0" rIns="0" bIns="0" anchor="t" anchorCtr="0">
               <a:spAutoFit/>
             </a:bodyPr>
             <a:lstStyle/>
@@ -14879,7 +14975,7 @@
           <p:spPr>
             <a:xfrm>
               <a:off x="1195197" y="6435725"/>
-              <a:ext cx="2013363" cy="191643"/>
+              <a:ext cx="2707203" cy="191643"/>
             </a:xfrm>
             <a:prstGeom prst="rect">
               <a:avLst/>
@@ -14890,7 +14986,7 @@
             </a:ln>
           </p:spPr>
           <p:txBody>
-            <a:bodyPr wrap="none" lIns="0" tIns="0" rIns="0" bIns="0" anchor="t" anchorCtr="0">
+            <a:bodyPr wrap="square" lIns="0" tIns="0" rIns="0" bIns="0" anchor="t" anchorCtr="0">
               <a:spAutoFit/>
             </a:bodyPr>
             <a:lstStyle/>
@@ -14912,22 +15008,34 @@
         </p:sp>
         <p:sp>
           <p:nvSpPr>
-            <p:cNvPr id="40" name="Rectangle 40"/>
+            <p:cNvPr id="40" name="Line 40"/>
             <p:cNvSpPr/>
             <p:nvPr/>
           </p:nvSpPr>
           <p:spPr>
             <a:xfrm>
-              <a:off x="11220450" y="6419850"/>
-              <a:ext cx="104775" cy="171450"/>
-            </a:xfrm>
-            <a:prstGeom prst="roundRect">
-              <a:avLst>
-                <a:gd name="adj" fmla="val 18182"/>
-              </a:avLst>
-            </a:prstGeom>
-            <a:noFill/>
-            <a:ln w="14288">
+              <a:off x="11068050" y="6515100"/>
+              <a:ext cx="190500" cy="9525"/>
+            </a:xfrm>
+            <a:custGeom>
+              <a:avLst/>
+              <a:gdLst/>
+              <a:ahLst/>
+              <a:cxnLst/>
+              <a:rect l="l" t="t" r="r" b="b"/>
+              <a:pathLst>
+                <a:path w="190500" h="9525">
+                  <a:moveTo>
+                    <a:pt x="0" y="0"/>
+                  </a:moveTo>
+                  <a:lnTo>
+                    <a:pt x="190500" y="0"/>
+                  </a:lnTo>
+                </a:path>
+              </a:pathLst>
+            </a:custGeom>
+            <a:noFill/>
+            <a:ln w="19050">
               <a:solidFill>
                 <a:srgbClr val="A8743A"/>
               </a:solidFill>
@@ -14942,8 +15050,8 @@
           </p:nvSpPr>
           <p:spPr>
             <a:xfrm>
-              <a:off x="11355622" y="6419850"/>
-              <a:ext cx="233255" cy="250317"/>
+              <a:off x="11154601" y="6419850"/>
+              <a:ext cx="434276" cy="250317"/>
             </a:xfrm>
             <a:prstGeom prst="rect">
               <a:avLst/>
@@ -14954,7 +15062,7 @@
             </a:ln>
           </p:spPr>
           <p:txBody>
-            <a:bodyPr wrap="none" lIns="0" tIns="0" rIns="0" bIns="0" anchor="t" anchorCtr="0">
+            <a:bodyPr wrap="square" lIns="0" tIns="0" rIns="0" bIns="0" anchor="t" anchorCtr="0">
               <a:spAutoFit/>
             </a:bodyPr>
             <a:lstStyle/>
@@ -15020,9 +15128,9 @@
         <p:grpSpPr>
           <a:xfrm>
             <a:off x="594360" y="565150"/>
-            <a:ext cx="9573410" cy="1118870"/>
+            <a:ext cx="8782495" cy="1118870"/>
             <a:chOff x="594360" y="565150"/>
-            <a:chExt cx="9573410" cy="1118870"/>
+            <a:chExt cx="8782495" cy="1118870"/>
           </a:xfrm>
         </p:grpSpPr>
         <p:sp>
@@ -15034,7 +15142,7 @@
           <p:spPr>
             <a:xfrm>
               <a:off x="603885" y="565150"/>
-              <a:ext cx="3030694" cy="220028"/>
+              <a:ext cx="3978867" cy="220028"/>
             </a:xfrm>
             <a:prstGeom prst="rect">
               <a:avLst/>
@@ -15045,7 +15153,7 @@
             </a:ln>
           </p:spPr>
           <p:txBody>
-            <a:bodyPr wrap="none" lIns="0" tIns="0" rIns="0" bIns="0" anchor="t" anchorCtr="0">
+            <a:bodyPr wrap="square" lIns="0" tIns="0" rIns="0" bIns="0" anchor="t" anchorCtr="0">
               <a:spAutoFit/>
             </a:bodyPr>
             <a:lstStyle/>
@@ -15074,7 +15182,7 @@
           <p:spPr>
             <a:xfrm>
               <a:off x="594360" y="850900"/>
-              <a:ext cx="9573410" cy="586740"/>
+              <a:ext cx="11168618" cy="586740"/>
             </a:xfrm>
             <a:prstGeom prst="rect">
               <a:avLst/>
@@ -15085,7 +15193,7 @@
             </a:ln>
           </p:spPr>
           <p:txBody>
-            <a:bodyPr wrap="none" lIns="0" tIns="0" rIns="0" bIns="0" anchor="t" anchorCtr="0">
+            <a:bodyPr wrap="square" lIns="0" tIns="0" rIns="0" bIns="0" anchor="t" anchorCtr="0">
               <a:spAutoFit/>
             </a:bodyPr>
             <a:lstStyle/>
@@ -15114,7 +15222,7 @@
           <p:spPr>
             <a:xfrm>
               <a:off x="601980" y="1390650"/>
-              <a:ext cx="5419303" cy="293370"/>
+              <a:ext cx="6964628" cy="293370"/>
             </a:xfrm>
             <a:prstGeom prst="rect">
               <a:avLst/>
@@ -15125,7 +15233,7 @@
             </a:ln>
           </p:spPr>
           <p:txBody>
-            <a:bodyPr wrap="none" lIns="0" tIns="0" rIns="0" bIns="0" anchor="t" anchorCtr="0">
+            <a:bodyPr wrap="square" lIns="0" tIns="0" rIns="0" bIns="0" anchor="t" anchorCtr="0">
               <a:spAutoFit/>
             </a:bodyPr>
             <a:lstStyle/>
@@ -15155,9 +15263,9 @@
         <p:grpSpPr>
           <a:xfrm>
             <a:off x="609600" y="2133600"/>
-            <a:ext cx="2813083" cy="3619500"/>
+            <a:ext cx="2575312" cy="3619500"/>
             <a:chOff x="609600" y="2133600"/>
-            <a:chExt cx="2813083" cy="3619500"/>
+            <a:chExt cx="2575312" cy="3619500"/>
           </a:xfrm>
         </p:grpSpPr>
         <p:sp>
@@ -15191,7 +15299,7 @@
           <p:spPr>
             <a:xfrm>
               <a:off x="901446" y="2432050"/>
-              <a:ext cx="2521237" cy="1813179"/>
+              <a:ext cx="3044832" cy="1813179"/>
             </a:xfrm>
             <a:prstGeom prst="rect">
               <a:avLst/>
@@ -15202,7 +15310,7 @@
             </a:ln>
           </p:spPr>
           <p:txBody>
-            <a:bodyPr wrap="none" lIns="0" tIns="0" rIns="0" bIns="0" anchor="t" anchorCtr="0">
+            <a:bodyPr wrap="square" lIns="0" tIns="0" rIns="0" bIns="0" anchor="t" anchorCtr="0">
               <a:spAutoFit/>
             </a:bodyPr>
             <a:lstStyle/>
@@ -15327,7 +15435,7 @@
             <p:spPr>
               <a:xfrm>
                 <a:off x="4490085" y="2241550"/>
-                <a:ext cx="601305" cy="220028"/>
+                <a:ext cx="942131" cy="220028"/>
               </a:xfrm>
               <a:prstGeom prst="rect">
                 <a:avLst/>
@@ -15338,7 +15446,7 @@
               </a:ln>
             </p:spPr>
             <p:txBody>
-              <a:bodyPr wrap="none" lIns="0" tIns="0" rIns="0" bIns="0" anchor="t" anchorCtr="0">
+              <a:bodyPr wrap="square" lIns="0" tIns="0" rIns="0" bIns="0" anchor="t" anchorCtr="0">
                 <a:spAutoFit/>
               </a:bodyPr>
               <a:lstStyle/>
@@ -15367,7 +15475,7 @@
             <p:spPr>
               <a:xfrm>
                 <a:off x="6087999" y="2190750"/>
-                <a:ext cx="3576545" cy="308991"/>
+                <a:ext cx="4661181" cy="308991"/>
               </a:xfrm>
               <a:prstGeom prst="rect">
                 <a:avLst/>
@@ -15378,7 +15486,7 @@
               </a:ln>
             </p:spPr>
             <p:txBody>
-              <a:bodyPr wrap="none" lIns="0" tIns="0" rIns="0" bIns="0" anchor="t" anchorCtr="0">
+              <a:bodyPr wrap="square" lIns="0" tIns="0" rIns="0" bIns="0" anchor="t" anchorCtr="0">
                 <a:spAutoFit/>
               </a:bodyPr>
               <a:lstStyle/>
@@ -15407,7 +15515,7 @@
             <p:spPr>
               <a:xfrm>
                 <a:off x="6089142" y="2501900"/>
-                <a:ext cx="3645935" cy="264033"/>
+                <a:ext cx="4747918" cy="264033"/>
               </a:xfrm>
               <a:prstGeom prst="rect">
                 <a:avLst/>
@@ -15418,7 +15526,7 @@
               </a:ln>
             </p:spPr>
             <p:txBody>
-              <a:bodyPr wrap="none" lIns="0" tIns="0" rIns="0" bIns="0" anchor="t" anchorCtr="0">
+              <a:bodyPr wrap="square" lIns="0" tIns="0" rIns="0" bIns="0" anchor="t" anchorCtr="0">
                 <a:spAutoFit/>
               </a:bodyPr>
               <a:lstStyle/>
@@ -15498,7 +15606,7 @@
             <p:spPr>
               <a:xfrm>
                 <a:off x="4490085" y="3251200"/>
-                <a:ext cx="517966" cy="220028"/>
+                <a:ext cx="837957" cy="220028"/>
               </a:xfrm>
               <a:prstGeom prst="rect">
                 <a:avLst/>
@@ -15509,7 +15617,7 @@
               </a:ln>
             </p:spPr>
             <p:txBody>
-              <a:bodyPr wrap="none" lIns="0" tIns="0" rIns="0" bIns="0" anchor="t" anchorCtr="0">
+              <a:bodyPr wrap="square" lIns="0" tIns="0" rIns="0" bIns="0" anchor="t" anchorCtr="0">
                 <a:spAutoFit/>
               </a:bodyPr>
               <a:lstStyle/>
@@ -15538,7 +15646,7 @@
             <p:spPr>
               <a:xfrm>
                 <a:off x="6087999" y="3200400"/>
-                <a:ext cx="1653534" cy="308991"/>
+                <a:ext cx="2257417" cy="308991"/>
               </a:xfrm>
               <a:prstGeom prst="rect">
                 <a:avLst/>
@@ -15549,7 +15657,7 @@
               </a:ln>
             </p:spPr>
             <p:txBody>
-              <a:bodyPr wrap="none" lIns="0" tIns="0" rIns="0" bIns="0" anchor="t" anchorCtr="0">
+              <a:bodyPr wrap="square" lIns="0" tIns="0" rIns="0" bIns="0" anchor="t" anchorCtr="0">
                 <a:spAutoFit/>
               </a:bodyPr>
               <a:lstStyle/>
@@ -15578,7 +15686,7 @@
             <p:spPr>
               <a:xfrm>
                 <a:off x="6089142" y="3511550"/>
-                <a:ext cx="4081397" cy="264033"/>
+                <a:ext cx="5292246" cy="264033"/>
               </a:xfrm>
               <a:prstGeom prst="rect">
                 <a:avLst/>
@@ -15589,7 +15697,7 @@
               </a:ln>
             </p:spPr>
             <p:txBody>
-              <a:bodyPr wrap="none" lIns="0" tIns="0" rIns="0" bIns="0" anchor="t" anchorCtr="0">
+              <a:bodyPr wrap="square" lIns="0" tIns="0" rIns="0" bIns="0" anchor="t" anchorCtr="0">
                 <a:spAutoFit/>
               </a:bodyPr>
               <a:lstStyle/>
@@ -15669,7 +15777,7 @@
             <p:spPr>
               <a:xfrm>
                 <a:off x="4490085" y="4260850"/>
-                <a:ext cx="927037" cy="220028"/>
+                <a:ext cx="1349296" cy="220028"/>
               </a:xfrm>
               <a:prstGeom prst="rect">
                 <a:avLst/>
@@ -15680,7 +15788,7 @@
               </a:ln>
             </p:spPr>
             <p:txBody>
-              <a:bodyPr wrap="none" lIns="0" tIns="0" rIns="0" bIns="0" anchor="t" anchorCtr="0">
+              <a:bodyPr wrap="square" lIns="0" tIns="0" rIns="0" bIns="0" anchor="t" anchorCtr="0">
                 <a:spAutoFit/>
               </a:bodyPr>
               <a:lstStyle/>
@@ -15709,7 +15817,7 @@
             <p:spPr>
               <a:xfrm>
                 <a:off x="6087999" y="4210050"/>
-                <a:ext cx="3463460" cy="308991"/>
+                <a:ext cx="4519825" cy="308991"/>
               </a:xfrm>
               <a:prstGeom prst="rect">
                 <a:avLst/>
@@ -15720,7 +15828,7 @@
               </a:ln>
             </p:spPr>
             <p:txBody>
-              <a:bodyPr wrap="none" lIns="0" tIns="0" rIns="0" bIns="0" anchor="t" anchorCtr="0">
+              <a:bodyPr wrap="square" lIns="0" tIns="0" rIns="0" bIns="0" anchor="t" anchorCtr="0">
                 <a:spAutoFit/>
               </a:bodyPr>
               <a:lstStyle/>
@@ -15749,7 +15857,7 @@
             <p:spPr>
               <a:xfrm>
                 <a:off x="6089142" y="4521200"/>
-                <a:ext cx="3788018" cy="264033"/>
+                <a:ext cx="4925522" cy="264033"/>
               </a:xfrm>
               <a:prstGeom prst="rect">
                 <a:avLst/>
@@ -15760,7 +15868,7 @@
               </a:ln>
             </p:spPr>
             <p:txBody>
-              <a:bodyPr wrap="none" lIns="0" tIns="0" rIns="0" bIns="0" anchor="t" anchorCtr="0">
+              <a:bodyPr wrap="square" lIns="0" tIns="0" rIns="0" bIns="0" anchor="t" anchorCtr="0">
                 <a:spAutoFit/>
               </a:bodyPr>
               <a:lstStyle/>
@@ -15840,7 +15948,7 @@
             <p:spPr>
               <a:xfrm>
                 <a:off x="4490085" y="5270500"/>
-                <a:ext cx="975232" cy="220028"/>
+                <a:ext cx="1409540" cy="220028"/>
               </a:xfrm>
               <a:prstGeom prst="rect">
                 <a:avLst/>
@@ -15851,7 +15959,7 @@
               </a:ln>
             </p:spPr>
             <p:txBody>
-              <a:bodyPr wrap="none" lIns="0" tIns="0" rIns="0" bIns="0" anchor="t" anchorCtr="0">
+              <a:bodyPr wrap="square" lIns="0" tIns="0" rIns="0" bIns="0" anchor="t" anchorCtr="0">
                 <a:spAutoFit/>
               </a:bodyPr>
               <a:lstStyle/>
@@ -15880,7 +15988,7 @@
             <p:spPr>
               <a:xfrm>
                 <a:off x="6087999" y="5219700"/>
-                <a:ext cx="2516993" cy="308991"/>
+                <a:ext cx="3336741" cy="308991"/>
               </a:xfrm>
               <a:prstGeom prst="rect">
                 <a:avLst/>
@@ -15891,7 +15999,7 @@
               </a:ln>
             </p:spPr>
             <p:txBody>
-              <a:bodyPr wrap="none" lIns="0" tIns="0" rIns="0" bIns="0" anchor="t" anchorCtr="0">
+              <a:bodyPr wrap="square" lIns="0" tIns="0" rIns="0" bIns="0" anchor="t" anchorCtr="0">
                 <a:spAutoFit/>
               </a:bodyPr>
               <a:lstStyle/>
@@ -15920,7 +16028,7 @@
             <p:spPr>
               <a:xfrm>
                 <a:off x="6089142" y="5530850"/>
-                <a:ext cx="4211653" cy="264033"/>
+                <a:ext cx="5455066" cy="264033"/>
               </a:xfrm>
               <a:prstGeom prst="rect">
                 <a:avLst/>
@@ -15931,7 +16039,7 @@
               </a:ln>
             </p:spPr>
             <p:txBody>
-              <a:bodyPr wrap="none" lIns="0" tIns="0" rIns="0" bIns="0" anchor="t" anchorCtr="0">
+              <a:bodyPr wrap="square" lIns="0" tIns="0" rIns="0" bIns="0" anchor="t" anchorCtr="0">
                 <a:spAutoFit/>
               </a:bodyPr>
               <a:lstStyle/>
@@ -15976,7 +16084,7 @@
           <p:spPr>
             <a:xfrm>
               <a:off x="603123" y="6419850"/>
-              <a:ext cx="547229" cy="250317"/>
+              <a:ext cx="839435" cy="250317"/>
             </a:xfrm>
             <a:prstGeom prst="rect">
               <a:avLst/>
@@ -15987,7 +16095,7 @@
             </a:ln>
           </p:spPr>
           <p:txBody>
-            <a:bodyPr wrap="none" lIns="0" tIns="0" rIns="0" bIns="0" anchor="t" anchorCtr="0">
+            <a:bodyPr wrap="square" lIns="0" tIns="0" rIns="0" bIns="0" anchor="t" anchorCtr="0">
               <a:spAutoFit/>
             </a:bodyPr>
             <a:lstStyle/>
@@ -16016,7 +16124,7 @@
           <p:spPr>
             <a:xfrm>
               <a:off x="1195197" y="6435725"/>
-              <a:ext cx="2013363" cy="191643"/>
+              <a:ext cx="2707203" cy="191643"/>
             </a:xfrm>
             <a:prstGeom prst="rect">
               <a:avLst/>
@@ -16027,7 +16135,7 @@
             </a:ln>
           </p:spPr>
           <p:txBody>
-            <a:bodyPr wrap="none" lIns="0" tIns="0" rIns="0" bIns="0" anchor="t" anchorCtr="0">
+            <a:bodyPr wrap="square" lIns="0" tIns="0" rIns="0" bIns="0" anchor="t" anchorCtr="0">
               <a:spAutoFit/>
             </a:bodyPr>
             <a:lstStyle/>
@@ -16049,22 +16157,34 @@
         </p:sp>
         <p:sp>
           <p:nvSpPr>
-            <p:cNvPr id="31" name="Rectangle 31"/>
+            <p:cNvPr id="31" name="Line 31"/>
             <p:cNvSpPr/>
             <p:nvPr/>
           </p:nvSpPr>
           <p:spPr>
             <a:xfrm>
-              <a:off x="11220450" y="6419850"/>
-              <a:ext cx="104775" cy="171450"/>
-            </a:xfrm>
-            <a:prstGeom prst="roundRect">
-              <a:avLst>
-                <a:gd name="adj" fmla="val 18182"/>
-              </a:avLst>
-            </a:prstGeom>
-            <a:noFill/>
-            <a:ln w="14288">
+              <a:off x="11068050" y="6515100"/>
+              <a:ext cx="190500" cy="9525"/>
+            </a:xfrm>
+            <a:custGeom>
+              <a:avLst/>
+              <a:gdLst/>
+              <a:ahLst/>
+              <a:cxnLst/>
+              <a:rect l="l" t="t" r="r" b="b"/>
+              <a:pathLst>
+                <a:path w="190500" h="9525">
+                  <a:moveTo>
+                    <a:pt x="0" y="0"/>
+                  </a:moveTo>
+                  <a:lnTo>
+                    <a:pt x="190500" y="0"/>
+                  </a:lnTo>
+                </a:path>
+              </a:pathLst>
+            </a:custGeom>
+            <a:noFill/>
+            <a:ln w="19050">
               <a:solidFill>
                 <a:srgbClr val="A8743A"/>
               </a:solidFill>
@@ -16079,8 +16199,8 @@
           </p:nvSpPr>
           <p:spPr>
             <a:xfrm>
-              <a:off x="11361138" y="6419850"/>
-              <a:ext cx="227739" cy="250317"/>
+              <a:off x="11154601" y="6419850"/>
+              <a:ext cx="434276" cy="250317"/>
             </a:xfrm>
             <a:prstGeom prst="rect">
               <a:avLst/>
@@ -16091,7 +16211,7 @@
             </a:ln>
           </p:spPr>
           <p:txBody>
-            <a:bodyPr wrap="none" lIns="0" tIns="0" rIns="0" bIns="0" anchor="t" anchorCtr="0">
+            <a:bodyPr wrap="square" lIns="0" tIns="0" rIns="0" bIns="0" anchor="t" anchorCtr="0">
               <a:spAutoFit/>
             </a:bodyPr>
             <a:lstStyle/>
@@ -16166,9 +16286,9 @@
     </a:clrScheme>
     <a:fontScheme name="knock">
       <a:majorFont>
-        <a:latin typeface="Georgia"/>
+        <a:latin typeface="Times New Roman"/>
         <a:ea typeface="SimSun"/>
-        <a:cs typeface="Georgia"/>
+        <a:cs typeface="Times New Roman"/>
         <a:font script="Jpan" typeface="SimSun"/>
         <a:font script="Hang" typeface="SimSun"/>
         <a:font script="Hans" typeface="SimSun"/>

</xml_diff>